<commit_message>
Add Feasibility, Viability, Impact, and System Benefits slides to SIH 26227 deck
- Expand PowerPoint generator script to 21 slides including technical/operational feasibility, commercial viability, and impact metrics
- Regenerate SIH_26227_Geospatial_Intelligence_Platform.pptx with updated dark navy and vivid azure styling
</commit_message>
<xml_diff>
--- a/SIH_PPT/SIH_26227_Geospatial_Intelligence_Platform.pptx
+++ b/SIH_PPT/SIH_26227_Geospatial_Intelligence_Platform.pptx
@@ -23,6 +23,9 @@
     <p:sldId id="271" r:id="rId22"/>
     <p:sldId id="272" r:id="rId23"/>
     <p:sldId id="273" r:id="rId24"/>
+    <p:sldId id="274" r:id="rId25"/>
+    <p:sldId id="275" r:id="rId26"/>
+    <p:sldId id="276" r:id="rId27"/>
   </p:sldIdLst>
   <p:sldSz cx="12191695" cy="6858000" type="screen4x3"/>
   <p:notesSz cx="6858000" cy="9144000"/>
@@ -3579,7 +3582,1372 @@
               </a:defRPr>
             </a:pPr>
             <a:r>
-              <a:t>Operational Deployment &amp; PS 26227 Coverage Matrix</a:t>
+              <a:t>Technical &amp; Operational Feasibility Analysis</a:t>
+            </a:r>
+          </a:p>
+        </p:txBody>
+      </p:sp>
+      <p:sp>
+        <p:nvSpPr>
+          <p:cNvPr id="4" name="Rounded Rectangle 3"/>
+          <p:cNvSpPr/>
+          <p:nvPr/>
+        </p:nvSpPr>
+        <p:spPr>
+          <a:xfrm>
+            <a:off x="731520" y="1371600"/>
+            <a:ext cx="5212080" cy="2286000"/>
+          </a:xfrm>
+          <a:prstGeom prst="roundRect">
+            <a:avLst/>
+          </a:prstGeom>
+          <a:solidFill>
+            <a:srgbClr val="0F172A"/>
+          </a:solidFill>
+          <a:ln w="19050">
+            <a:solidFill>
+              <a:srgbClr val="00D2FF"/>
+            </a:solidFill>
+          </a:ln>
+        </p:spPr>
+        <p:style>
+          <a:lnRef idx="1">
+            <a:schemeClr val="accent1"/>
+          </a:lnRef>
+          <a:fillRef idx="3">
+            <a:schemeClr val="accent1"/>
+          </a:fillRef>
+          <a:effectRef idx="2">
+            <a:schemeClr val="accent1"/>
+          </a:effectRef>
+          <a:fontRef idx="minor">
+            <a:schemeClr val="lt1"/>
+          </a:fontRef>
+        </p:style>
+        <p:txBody>
+          <a:bodyPr rtlCol="0" anchor="ctr"/>
+          <a:lstStyle/>
+          <a:p>
+            <a:pPr algn="ctr"/>
+          </a:p>
+        </p:txBody>
+      </p:sp>
+      <p:sp>
+        <p:nvSpPr>
+          <p:cNvPr id="5" name="TextBox 4"/>
+          <p:cNvSpPr txBox="1"/>
+          <p:nvPr/>
+        </p:nvSpPr>
+        <p:spPr>
+          <a:xfrm>
+            <a:off x="914400" y="1554480"/>
+            <a:ext cx="4846320" cy="1920240"/>
+          </a:xfrm>
+          <a:prstGeom prst="rect">
+            <a:avLst/>
+          </a:prstGeom>
+          <a:noFill/>
+        </p:spPr>
+        <p:txBody>
+          <a:bodyPr wrap="square">
+            <a:spAutoFit/>
+          </a:bodyPr>
+          <a:lstStyle/>
+          <a:p>
+            <a:pPr>
+              <a:defRPr sz="1300" b="1">
+                <a:solidFill>
+                  <a:srgbClr val="00D2FF"/>
+                </a:solidFill>
+              </a:defRPr>
+            </a:pPr>
+            <a:r>
+              <a:t>HARDWARE &amp; EDGE FEASIBILITY</a:t>
+            </a:r>
+          </a:p>
+          <a:p>
+            <a:pPr>
+              <a:defRPr sz="1100">
+                <a:solidFill>
+                  <a:srgbClr val="FFFFFF"/>
+                </a:solidFill>
+              </a:defRPr>
+            </a:pPr>
+            <a:r>
+              <a:t>Runs on standard military workstation hardware or tactical edge servers (NVIDIA Orin/RTX). Minimum requirements: 16GB RAM, 4-core CPU, optional GPU acceleration.</a:t>
+            </a:r>
+          </a:p>
+        </p:txBody>
+      </p:sp>
+      <p:sp>
+        <p:nvSpPr>
+          <p:cNvPr id="6" name="Rounded Rectangle 5"/>
+          <p:cNvSpPr/>
+          <p:nvPr/>
+        </p:nvSpPr>
+        <p:spPr>
+          <a:xfrm>
+            <a:off x="6172200" y="1371600"/>
+            <a:ext cx="5212080" cy="2286000"/>
+          </a:xfrm>
+          <a:prstGeom prst="roundRect">
+            <a:avLst/>
+          </a:prstGeom>
+          <a:solidFill>
+            <a:srgbClr val="0F172A"/>
+          </a:solidFill>
+          <a:ln w="19050">
+            <a:solidFill>
+              <a:srgbClr val="007AFF"/>
+            </a:solidFill>
+          </a:ln>
+        </p:spPr>
+        <p:style>
+          <a:lnRef idx="1">
+            <a:schemeClr val="accent1"/>
+          </a:lnRef>
+          <a:fillRef idx="3">
+            <a:schemeClr val="accent1"/>
+          </a:fillRef>
+          <a:effectRef idx="2">
+            <a:schemeClr val="accent1"/>
+          </a:effectRef>
+          <a:fontRef idx="minor">
+            <a:schemeClr val="lt1"/>
+          </a:fontRef>
+        </p:style>
+        <p:txBody>
+          <a:bodyPr rtlCol="0" anchor="ctr"/>
+          <a:lstStyle/>
+          <a:p>
+            <a:pPr algn="ctr"/>
+          </a:p>
+        </p:txBody>
+      </p:sp>
+      <p:sp>
+        <p:nvSpPr>
+          <p:cNvPr id="7" name="TextBox 6"/>
+          <p:cNvSpPr txBox="1"/>
+          <p:nvPr/>
+        </p:nvSpPr>
+        <p:spPr>
+          <a:xfrm>
+            <a:off x="6355080" y="1554480"/>
+            <a:ext cx="4846320" cy="1920240"/>
+          </a:xfrm>
+          <a:prstGeom prst="rect">
+            <a:avLst/>
+          </a:prstGeom>
+          <a:noFill/>
+        </p:spPr>
+        <p:txBody>
+          <a:bodyPr wrap="square">
+            <a:spAutoFit/>
+          </a:bodyPr>
+          <a:lstStyle/>
+          <a:p>
+            <a:pPr>
+              <a:defRPr sz="1300" b="1">
+                <a:solidFill>
+                  <a:srgbClr val="007AFF"/>
+                </a:solidFill>
+              </a:defRPr>
+            </a:pPr>
+            <a:r>
+              <a:t>DATA SOURCE INTEGRATION</a:t>
+            </a:r>
+          </a:p>
+          <a:p>
+            <a:pPr>
+              <a:defRPr sz="1100">
+                <a:solidFill>
+                  <a:srgbClr val="FFFFFF"/>
+                </a:solidFill>
+              </a:defRPr>
+            </a:pPr>
+            <a:r>
+              <a:t>Seamlessly ingests open Earth Observation archives (Sentinel-2, Landsat-8/9, PlanetScope COGs) using standard STAC catalogs and GeoTIFF drivers.</a:t>
+            </a:r>
+          </a:p>
+        </p:txBody>
+      </p:sp>
+      <p:sp>
+        <p:nvSpPr>
+          <p:cNvPr id="8" name="Rounded Rectangle 7"/>
+          <p:cNvSpPr/>
+          <p:nvPr/>
+        </p:nvSpPr>
+        <p:spPr>
+          <a:xfrm>
+            <a:off x="731520" y="3840480"/>
+            <a:ext cx="5212080" cy="2286000"/>
+          </a:xfrm>
+          <a:prstGeom prst="roundRect">
+            <a:avLst/>
+          </a:prstGeom>
+          <a:solidFill>
+            <a:srgbClr val="0F172A"/>
+          </a:solidFill>
+          <a:ln w="19050">
+            <a:solidFill>
+              <a:srgbClr val="00D2FF"/>
+            </a:solidFill>
+          </a:ln>
+        </p:spPr>
+        <p:style>
+          <a:lnRef idx="1">
+            <a:schemeClr val="accent1"/>
+          </a:lnRef>
+          <a:fillRef idx="3">
+            <a:schemeClr val="accent1"/>
+          </a:fillRef>
+          <a:effectRef idx="2">
+            <a:schemeClr val="accent1"/>
+          </a:effectRef>
+          <a:fontRef idx="minor">
+            <a:schemeClr val="lt1"/>
+          </a:fontRef>
+        </p:style>
+        <p:txBody>
+          <a:bodyPr rtlCol="0" anchor="ctr"/>
+          <a:lstStyle/>
+          <a:p>
+            <a:pPr algn="ctr"/>
+          </a:p>
+        </p:txBody>
+      </p:sp>
+      <p:sp>
+        <p:nvSpPr>
+          <p:cNvPr id="9" name="TextBox 8"/>
+          <p:cNvSpPr txBox="1"/>
+          <p:nvPr/>
+        </p:nvSpPr>
+        <p:spPr>
+          <a:xfrm>
+            <a:off x="914400" y="4023360"/>
+            <a:ext cx="4846320" cy="1920240"/>
+          </a:xfrm>
+          <a:prstGeom prst="rect">
+            <a:avLst/>
+          </a:prstGeom>
+          <a:noFill/>
+        </p:spPr>
+        <p:txBody>
+          <a:bodyPr wrap="square">
+            <a:spAutoFit/>
+          </a:bodyPr>
+          <a:lstStyle/>
+          <a:p>
+            <a:pPr>
+              <a:defRPr sz="1300" b="1">
+                <a:solidFill>
+                  <a:srgbClr val="00D2FF"/>
+                </a:solidFill>
+              </a:defRPr>
+            </a:pPr>
+            <a:r>
+              <a:t>ALGORITHMIC MATURITY</a:t>
+            </a:r>
+          </a:p>
+          <a:p>
+            <a:pPr>
+              <a:defRPr sz="1100">
+                <a:solidFill>
+                  <a:srgbClr val="FFFFFF"/>
+                </a:solidFill>
+              </a:defRPr>
+            </a:pPr>
+            <a:r>
+              <a:t>Uses proven, highly optimized open-weights VLM transformer backbones (OpenCLIP) and PostGIS spatial indexing with zero proprietary cloud locks.</a:t>
+            </a:r>
+          </a:p>
+        </p:txBody>
+      </p:sp>
+      <p:sp>
+        <p:nvSpPr>
+          <p:cNvPr id="10" name="Rounded Rectangle 9"/>
+          <p:cNvSpPr/>
+          <p:nvPr/>
+        </p:nvSpPr>
+        <p:spPr>
+          <a:xfrm>
+            <a:off x="6172200" y="3840480"/>
+            <a:ext cx="5212080" cy="2286000"/>
+          </a:xfrm>
+          <a:prstGeom prst="roundRect">
+            <a:avLst/>
+          </a:prstGeom>
+          <a:solidFill>
+            <a:srgbClr val="0F172A"/>
+          </a:solidFill>
+          <a:ln w="19050">
+            <a:solidFill>
+              <a:srgbClr val="007AFF"/>
+            </a:solidFill>
+          </a:ln>
+        </p:spPr>
+        <p:style>
+          <a:lnRef idx="1">
+            <a:schemeClr val="accent1"/>
+          </a:lnRef>
+          <a:fillRef idx="3">
+            <a:schemeClr val="accent1"/>
+          </a:fillRef>
+          <a:effectRef idx="2">
+            <a:schemeClr val="accent1"/>
+          </a:effectRef>
+          <a:fontRef idx="minor">
+            <a:schemeClr val="lt1"/>
+          </a:fontRef>
+        </p:style>
+        <p:txBody>
+          <a:bodyPr rtlCol="0" anchor="ctr"/>
+          <a:lstStyle/>
+          <a:p>
+            <a:pPr algn="ctr"/>
+          </a:p>
+        </p:txBody>
+      </p:sp>
+      <p:sp>
+        <p:nvSpPr>
+          <p:cNvPr id="11" name="TextBox 10"/>
+          <p:cNvSpPr txBox="1"/>
+          <p:nvPr/>
+        </p:nvSpPr>
+        <p:spPr>
+          <a:xfrm>
+            <a:off x="6355080" y="4023360"/>
+            <a:ext cx="4846320" cy="1920240"/>
+          </a:xfrm>
+          <a:prstGeom prst="rect">
+            <a:avLst/>
+          </a:prstGeom>
+          <a:noFill/>
+        </p:spPr>
+        <p:txBody>
+          <a:bodyPr wrap="square">
+            <a:spAutoFit/>
+          </a:bodyPr>
+          <a:lstStyle/>
+          <a:p>
+            <a:pPr>
+              <a:defRPr sz="1300" b="1">
+                <a:solidFill>
+                  <a:srgbClr val="007AFF"/>
+                </a:solidFill>
+              </a:defRPr>
+            </a:pPr>
+            <a:r>
+              <a:t>HUMAN-IN-THE-LOOP DESIGN</a:t>
+            </a:r>
+          </a:p>
+          <a:p>
+            <a:pPr>
+              <a:defRPr sz="1100">
+                <a:solidFill>
+                  <a:srgbClr val="FFFFFF"/>
+                </a:solidFill>
+              </a:defRPr>
+            </a:pPr>
+            <a:r>
+              <a:t>Augments analyst decision-making rather than replacing it. Confidence ranking and split-screen visual evidence ensure immediate operational adoption.</a:t>
+            </a:r>
+          </a:p>
+        </p:txBody>
+      </p:sp>
+    </p:spTree>
+  </p:cSld>
+  <p:clrMapOvr>
+    <a:masterClrMapping/>
+  </p:clrMapOvr>
+</p:sld>
+</file>
+
+<file path=ppt/slides/slide11.xml><?xml version="1.0" encoding="utf-8"?>
+<p:sld xmlns:a="http://schemas.openxmlformats.org/drawingml/2006/main" xmlns:p="http://schemas.openxmlformats.org/presentationml/2006/main" xmlns:r="http://schemas.openxmlformats.org/officeDocument/2006/relationships">
+  <p:cSld>
+    <p:bg>
+      <p:bgPr>
+        <a:solidFill>
+          <a:srgbClr val="0B1120"/>
+        </a:solidFill>
+        <a:effectLst/>
+      </p:bgPr>
+    </p:bg>
+    <p:spTree>
+      <p:nvGrpSpPr>
+        <p:cNvPr id="1" name=""/>
+        <p:cNvGrpSpPr/>
+        <p:nvPr/>
+      </p:nvGrpSpPr>
+      <p:grpSpPr/>
+      <p:sp>
+        <p:nvSpPr>
+          <p:cNvPr id="2" name="TextBox 1"/>
+          <p:cNvSpPr txBox="1"/>
+          <p:nvPr/>
+        </p:nvSpPr>
+        <p:spPr>
+          <a:xfrm>
+            <a:off x="731520" y="365760"/>
+            <a:ext cx="10728655" cy="274320"/>
+          </a:xfrm>
+          <a:prstGeom prst="rect">
+            <a:avLst/>
+          </a:prstGeom>
+          <a:noFill/>
+        </p:spPr>
+        <p:txBody>
+          <a:bodyPr wrap="square">
+            <a:spAutoFit/>
+          </a:bodyPr>
+          <a:lstStyle/>
+          <a:p>
+            <a:pPr>
+              <a:defRPr sz="1000" b="1">
+                <a:solidFill>
+                  <a:srgbClr val="00D2FF"/>
+                </a:solidFill>
+                <a:latin typeface="Helvetica"/>
+              </a:defRPr>
+            </a:pPr>
+            <a:r>
+              <a:t>SIH 2026 PS 26227 | GEOSPATIAL INTELLIGENCE PLATFORM</a:t>
+            </a:r>
+          </a:p>
+        </p:txBody>
+      </p:sp>
+      <p:sp>
+        <p:nvSpPr>
+          <p:cNvPr id="3" name="TextBox 2"/>
+          <p:cNvSpPr txBox="1"/>
+          <p:nvPr/>
+        </p:nvSpPr>
+        <p:spPr>
+          <a:xfrm>
+            <a:off x="731520" y="594360"/>
+            <a:ext cx="10728655" cy="548640"/>
+          </a:xfrm>
+          <a:prstGeom prst="rect">
+            <a:avLst/>
+          </a:prstGeom>
+          <a:noFill/>
+        </p:spPr>
+        <p:txBody>
+          <a:bodyPr wrap="square">
+            <a:spAutoFit/>
+          </a:bodyPr>
+          <a:lstStyle/>
+          <a:p>
+            <a:pPr>
+              <a:defRPr sz="2200" b="1">
+                <a:solidFill>
+                  <a:srgbClr val="FFFFFF"/>
+                </a:solidFill>
+                <a:latin typeface="Helvetica"/>
+              </a:defRPr>
+            </a:pPr>
+            <a:r>
+              <a:t>Commercial &amp; Strategic Viability</a:t>
+            </a:r>
+          </a:p>
+        </p:txBody>
+      </p:sp>
+      <p:sp>
+        <p:nvSpPr>
+          <p:cNvPr id="4" name="Rounded Rectangle 3"/>
+          <p:cNvSpPr/>
+          <p:nvPr/>
+        </p:nvSpPr>
+        <p:spPr>
+          <a:xfrm>
+            <a:off x="731520" y="1371600"/>
+            <a:ext cx="3474720" cy="4937760"/>
+          </a:xfrm>
+          <a:prstGeom prst="roundRect">
+            <a:avLst/>
+          </a:prstGeom>
+          <a:solidFill>
+            <a:srgbClr val="0F172A"/>
+          </a:solidFill>
+          <a:ln w="19050">
+            <a:solidFill>
+              <a:srgbClr val="00D2FF"/>
+            </a:solidFill>
+          </a:ln>
+        </p:spPr>
+        <p:style>
+          <a:lnRef idx="1">
+            <a:schemeClr val="accent1"/>
+          </a:lnRef>
+          <a:fillRef idx="3">
+            <a:schemeClr val="accent1"/>
+          </a:fillRef>
+          <a:effectRef idx="2">
+            <a:schemeClr val="accent1"/>
+          </a:effectRef>
+          <a:fontRef idx="minor">
+            <a:schemeClr val="lt1"/>
+          </a:fontRef>
+        </p:style>
+        <p:txBody>
+          <a:bodyPr rtlCol="0" anchor="ctr"/>
+          <a:lstStyle/>
+          <a:p>
+            <a:pPr algn="ctr"/>
+          </a:p>
+        </p:txBody>
+      </p:sp>
+      <p:sp>
+        <p:nvSpPr>
+          <p:cNvPr id="5" name="TextBox 4"/>
+          <p:cNvSpPr txBox="1"/>
+          <p:nvPr/>
+        </p:nvSpPr>
+        <p:spPr>
+          <a:xfrm>
+            <a:off x="914400" y="1554480"/>
+            <a:ext cx="3108960" cy="4572000"/>
+          </a:xfrm>
+          <a:prstGeom prst="rect">
+            <a:avLst/>
+          </a:prstGeom>
+          <a:noFill/>
+        </p:spPr>
+        <p:txBody>
+          <a:bodyPr wrap="square">
+            <a:spAutoFit/>
+          </a:bodyPr>
+          <a:lstStyle/>
+          <a:p>
+            <a:pPr>
+              <a:defRPr sz="1300" b="1">
+                <a:solidFill>
+                  <a:srgbClr val="00D2FF"/>
+                </a:solidFill>
+              </a:defRPr>
+            </a:pPr>
+            <a:r>
+              <a:t>ZERO RECURRING LICENSING</a:t>
+            </a:r>
+          </a:p>
+          <a:p>
+            <a:pPr>
+              <a:defRPr sz="1100">
+                <a:solidFill>
+                  <a:srgbClr val="FFFFFF"/>
+                </a:solidFill>
+              </a:defRPr>
+            </a:pPr>
+            <a:r>
+              <a:t>Built entirely on open-source stack (FastAPI, PyTorch, PostGIS, MapLibre GL). No ongoing per-user or per-gigabyte commercial API fees.</a:t>
+            </a:r>
+          </a:p>
+        </p:txBody>
+      </p:sp>
+      <p:sp>
+        <p:nvSpPr>
+          <p:cNvPr id="6" name="Rounded Rectangle 5"/>
+          <p:cNvSpPr/>
+          <p:nvPr/>
+        </p:nvSpPr>
+        <p:spPr>
+          <a:xfrm>
+            <a:off x="4343400" y="1371600"/>
+            <a:ext cx="3474720" cy="4937760"/>
+          </a:xfrm>
+          <a:prstGeom prst="roundRect">
+            <a:avLst/>
+          </a:prstGeom>
+          <a:solidFill>
+            <a:srgbClr val="0F172A"/>
+          </a:solidFill>
+          <a:ln w="19050">
+            <a:solidFill>
+              <a:srgbClr val="00D2FF"/>
+            </a:solidFill>
+          </a:ln>
+        </p:spPr>
+        <p:style>
+          <a:lnRef idx="1">
+            <a:schemeClr val="accent1"/>
+          </a:lnRef>
+          <a:fillRef idx="3">
+            <a:schemeClr val="accent1"/>
+          </a:fillRef>
+          <a:effectRef idx="2">
+            <a:schemeClr val="accent1"/>
+          </a:effectRef>
+          <a:fontRef idx="minor">
+            <a:schemeClr val="lt1"/>
+          </a:fontRef>
+        </p:style>
+        <p:txBody>
+          <a:bodyPr rtlCol="0" anchor="ctr"/>
+          <a:lstStyle/>
+          <a:p>
+            <a:pPr algn="ctr"/>
+          </a:p>
+        </p:txBody>
+      </p:sp>
+      <p:sp>
+        <p:nvSpPr>
+          <p:cNvPr id="7" name="TextBox 6"/>
+          <p:cNvSpPr txBox="1"/>
+          <p:nvPr/>
+        </p:nvSpPr>
+        <p:spPr>
+          <a:xfrm>
+            <a:off x="4526280" y="1554480"/>
+            <a:ext cx="3108960" cy="4572000"/>
+          </a:xfrm>
+          <a:prstGeom prst="rect">
+            <a:avLst/>
+          </a:prstGeom>
+          <a:noFill/>
+        </p:spPr>
+        <p:txBody>
+          <a:bodyPr wrap="square">
+            <a:spAutoFit/>
+          </a:bodyPr>
+          <a:lstStyle/>
+          <a:p>
+            <a:pPr>
+              <a:defRPr sz="1300" b="1">
+                <a:solidFill>
+                  <a:srgbClr val="00D2FF"/>
+                </a:solidFill>
+              </a:defRPr>
+            </a:pPr>
+            <a:r>
+              <a:t>AIR-GAPPED FIELD READY</a:t>
+            </a:r>
+          </a:p>
+          <a:p>
+            <a:pPr>
+              <a:defRPr sz="1100">
+                <a:solidFill>
+                  <a:srgbClr val="FFFFFF"/>
+                </a:solidFill>
+              </a:defRPr>
+            </a:pPr>
+            <a:r>
+              <a:t>100% local deployment eliminates cloud bandwidth, egress costs, and satellite uplink vulnerabilities in disconnected environments.</a:t>
+            </a:r>
+          </a:p>
+        </p:txBody>
+      </p:sp>
+      <p:sp>
+        <p:nvSpPr>
+          <p:cNvPr id="8" name="Rounded Rectangle 7"/>
+          <p:cNvSpPr/>
+          <p:nvPr/>
+        </p:nvSpPr>
+        <p:spPr>
+          <a:xfrm>
+            <a:off x="7955280" y="1371600"/>
+            <a:ext cx="3474720" cy="4937760"/>
+          </a:xfrm>
+          <a:prstGeom prst="roundRect">
+            <a:avLst/>
+          </a:prstGeom>
+          <a:solidFill>
+            <a:srgbClr val="0F172A"/>
+          </a:solidFill>
+          <a:ln w="19050">
+            <a:solidFill>
+              <a:srgbClr val="00D2FF"/>
+            </a:solidFill>
+          </a:ln>
+        </p:spPr>
+        <p:style>
+          <a:lnRef idx="1">
+            <a:schemeClr val="accent1"/>
+          </a:lnRef>
+          <a:fillRef idx="3">
+            <a:schemeClr val="accent1"/>
+          </a:fillRef>
+          <a:effectRef idx="2">
+            <a:schemeClr val="accent1"/>
+          </a:effectRef>
+          <a:fontRef idx="minor">
+            <a:schemeClr val="lt1"/>
+          </a:fontRef>
+        </p:style>
+        <p:txBody>
+          <a:bodyPr rtlCol="0" anchor="ctr"/>
+          <a:lstStyle/>
+          <a:p>
+            <a:pPr algn="ctr"/>
+          </a:p>
+        </p:txBody>
+      </p:sp>
+      <p:sp>
+        <p:nvSpPr>
+          <p:cNvPr id="9" name="TextBox 8"/>
+          <p:cNvSpPr txBox="1"/>
+          <p:nvPr/>
+        </p:nvSpPr>
+        <p:spPr>
+          <a:xfrm>
+            <a:off x="8138160" y="1554480"/>
+            <a:ext cx="3108960" cy="4572000"/>
+          </a:xfrm>
+          <a:prstGeom prst="rect">
+            <a:avLst/>
+          </a:prstGeom>
+          <a:noFill/>
+        </p:spPr>
+        <p:txBody>
+          <a:bodyPr wrap="square">
+            <a:spAutoFit/>
+          </a:bodyPr>
+          <a:lstStyle/>
+          <a:p>
+            <a:pPr>
+              <a:defRPr sz="1300" b="1">
+                <a:solidFill>
+                  <a:srgbClr val="00D2FF"/>
+                </a:solidFill>
+              </a:defRPr>
+            </a:pPr>
+            <a:r>
+              <a:t>INCREMENTAL SCALABILITY</a:t>
+            </a:r>
+          </a:p>
+          <a:p>
+            <a:pPr>
+              <a:defRPr sz="1100">
+                <a:solidFill>
+                  <a:srgbClr val="FFFFFF"/>
+                </a:solidFill>
+              </a:defRPr>
+            </a:pPr>
+            <a:r>
+              <a:t>Modular architecture allows seamless expansion from single tactical field laptops to command-center server clusters.</a:t>
+            </a:r>
+          </a:p>
+        </p:txBody>
+      </p:sp>
+    </p:spTree>
+  </p:cSld>
+  <p:clrMapOvr>
+    <a:masterClrMapping/>
+  </p:clrMapOvr>
+</p:sld>
+</file>
+
+<file path=ppt/slides/slide12.xml><?xml version="1.0" encoding="utf-8"?>
+<p:sld xmlns:a="http://schemas.openxmlformats.org/drawingml/2006/main" xmlns:p="http://schemas.openxmlformats.org/presentationml/2006/main" xmlns:r="http://schemas.openxmlformats.org/officeDocument/2006/relationships">
+  <p:cSld>
+    <p:bg>
+      <p:bgPr>
+        <a:solidFill>
+          <a:srgbClr val="0B1120"/>
+        </a:solidFill>
+        <a:effectLst/>
+      </p:bgPr>
+    </p:bg>
+    <p:spTree>
+      <p:nvGrpSpPr>
+        <p:cNvPr id="1" name=""/>
+        <p:cNvGrpSpPr/>
+        <p:nvPr/>
+      </p:nvGrpSpPr>
+      <p:grpSpPr/>
+      <p:sp>
+        <p:nvSpPr>
+          <p:cNvPr id="2" name="TextBox 1"/>
+          <p:cNvSpPr txBox="1"/>
+          <p:nvPr/>
+        </p:nvSpPr>
+        <p:spPr>
+          <a:xfrm>
+            <a:off x="731520" y="365760"/>
+            <a:ext cx="10728655" cy="274320"/>
+          </a:xfrm>
+          <a:prstGeom prst="rect">
+            <a:avLst/>
+          </a:prstGeom>
+          <a:noFill/>
+        </p:spPr>
+        <p:txBody>
+          <a:bodyPr wrap="square">
+            <a:spAutoFit/>
+          </a:bodyPr>
+          <a:lstStyle/>
+          <a:p>
+            <a:pPr>
+              <a:defRPr sz="1000" b="1">
+                <a:solidFill>
+                  <a:srgbClr val="00D2FF"/>
+                </a:solidFill>
+                <a:latin typeface="Helvetica"/>
+              </a:defRPr>
+            </a:pPr>
+            <a:r>
+              <a:t>SIH 2026 PS 26227 | GEOSPATIAL INTELLIGENCE PLATFORM</a:t>
+            </a:r>
+          </a:p>
+        </p:txBody>
+      </p:sp>
+      <p:sp>
+        <p:nvSpPr>
+          <p:cNvPr id="3" name="TextBox 2"/>
+          <p:cNvSpPr txBox="1"/>
+          <p:nvPr/>
+        </p:nvSpPr>
+        <p:spPr>
+          <a:xfrm>
+            <a:off x="731520" y="594360"/>
+            <a:ext cx="10728655" cy="548640"/>
+          </a:xfrm>
+          <a:prstGeom prst="rect">
+            <a:avLst/>
+          </a:prstGeom>
+          <a:noFill/>
+        </p:spPr>
+        <p:txBody>
+          <a:bodyPr wrap="square">
+            <a:spAutoFit/>
+          </a:bodyPr>
+          <a:lstStyle/>
+          <a:p>
+            <a:pPr>
+              <a:defRPr sz="2200" b="1">
+                <a:solidFill>
+                  <a:srgbClr val="FFFFFF"/>
+                </a:solidFill>
+                <a:latin typeface="Helvetica"/>
+              </a:defRPr>
+            </a:pPr>
+            <a:r>
+              <a:t>Operational Impact &amp; Measurable Benefits</a:t>
+            </a:r>
+          </a:p>
+        </p:txBody>
+      </p:sp>
+      <p:sp>
+        <p:nvSpPr>
+          <p:cNvPr id="4" name="Rounded Rectangle 3"/>
+          <p:cNvSpPr/>
+          <p:nvPr/>
+        </p:nvSpPr>
+        <p:spPr>
+          <a:xfrm>
+            <a:off x="731520" y="1280160"/>
+            <a:ext cx="10728655" cy="5029200"/>
+          </a:xfrm>
+          <a:prstGeom prst="roundRect">
+            <a:avLst/>
+          </a:prstGeom>
+          <a:solidFill>
+            <a:srgbClr val="0F172A"/>
+          </a:solidFill>
+          <a:ln w="19050">
+            <a:solidFill>
+              <a:srgbClr val="007AFF"/>
+            </a:solidFill>
+          </a:ln>
+        </p:spPr>
+        <p:style>
+          <a:lnRef idx="1">
+            <a:schemeClr val="accent1"/>
+          </a:lnRef>
+          <a:fillRef idx="3">
+            <a:schemeClr val="accent1"/>
+          </a:fillRef>
+          <a:effectRef idx="2">
+            <a:schemeClr val="accent1"/>
+          </a:effectRef>
+          <a:fontRef idx="minor">
+            <a:schemeClr val="lt1"/>
+          </a:fontRef>
+        </p:style>
+        <p:txBody>
+          <a:bodyPr rtlCol="0" anchor="ctr"/>
+          <a:lstStyle/>
+          <a:p>
+            <a:pPr algn="ctr"/>
+          </a:p>
+        </p:txBody>
+      </p:sp>
+      <p:graphicFrame>
+        <p:nvGraphicFramePr>
+          <p:cNvPr id="5" name="Table 4"/>
+          <p:cNvGraphicFramePr>
+            <a:graphicFrameLocks noGrp="1"/>
+          </p:cNvGraphicFramePr>
+          <p:nvPr/>
+        </p:nvGraphicFramePr>
+        <p:xfrm>
+          <a:off x="914400" y="1463040"/>
+          <a:ext cx="10362895" cy="4663440"/>
+        </p:xfrm>
+        <a:graphic>
+          <a:graphicData uri="http://schemas.openxmlformats.org/drawingml/2006/table">
+            <a:tbl>
+              <a:tblPr firstRow="1" bandRow="1">
+                <a:tableStyleId>{5C22544A-7EE6-4342-B048-85BDC9FD1C3A}</a:tableStyleId>
+              </a:tblPr>
+              <a:tblGrid>
+                <a:gridCol w="2560320"/>
+                <a:gridCol w="3840480"/>
+                <a:gridCol w="3962095"/>
+              </a:tblGrid>
+              <a:tr h="932688">
+                <a:tc>
+                  <a:txBody>
+                    <a:bodyPr/>
+                    <a:lstStyle/>
+                    <a:p>
+                      <a:pPr>
+                        <a:defRPr sz="1100" b="1">
+                          <a:solidFill>
+                            <a:srgbClr val="00D2FF"/>
+                          </a:solidFill>
+                        </a:defRPr>
+                      </a:pPr>
+                      <a:r>
+                        <a:t>Operational Dimension</a:t>
+                      </a:r>
+                    </a:p>
+                  </a:txBody>
+                  <a:tcPr>
+                    <a:solidFill>
+                      <a:srgbClr val="1E293B"/>
+                    </a:solidFill>
+                  </a:tcPr>
+                </a:tc>
+                <a:tc>
+                  <a:txBody>
+                    <a:bodyPr/>
+                    <a:lstStyle/>
+                    <a:p>
+                      <a:pPr>
+                        <a:defRPr sz="1100" b="1">
+                          <a:solidFill>
+                            <a:srgbClr val="00D2FF"/>
+                          </a:solidFill>
+                        </a:defRPr>
+                      </a:pPr>
+                      <a:r>
+                        <a:t>Traditional EO Workflow</a:t>
+                      </a:r>
+                    </a:p>
+                  </a:txBody>
+                  <a:tcPr>
+                    <a:solidFill>
+                      <a:srgbClr val="1E293B"/>
+                    </a:solidFill>
+                  </a:tcPr>
+                </a:tc>
+                <a:tc>
+                  <a:txBody>
+                    <a:bodyPr/>
+                    <a:lstStyle/>
+                    <a:p>
+                      <a:pPr>
+                        <a:defRPr sz="1100" b="1">
+                          <a:solidFill>
+                            <a:srgbClr val="00D2FF"/>
+                          </a:solidFill>
+                        </a:defRPr>
+                      </a:pPr>
+                      <a:r>
+                        <a:t>With Platform</a:t>
+                      </a:r>
+                    </a:p>
+                  </a:txBody>
+                  <a:tcPr>
+                    <a:solidFill>
+                      <a:srgbClr val="1E293B"/>
+                    </a:solidFill>
+                  </a:tcPr>
+                </a:tc>
+              </a:tr>
+              <a:tr h="932688">
+                <a:tc>
+                  <a:txBody>
+                    <a:bodyPr/>
+                    <a:lstStyle/>
+                    <a:p>
+                      <a:pPr>
+                        <a:defRPr sz="1050">
+                          <a:solidFill>
+                            <a:srgbClr val="FFFFFF"/>
+                          </a:solidFill>
+                        </a:defRPr>
+                      </a:pPr>
+                      <a:r>
+                        <a:t>Query Discovery Time</a:t>
+                      </a:r>
+                    </a:p>
+                  </a:txBody>
+                  <a:tcPr>
+                    <a:solidFill>
+                      <a:srgbClr val="0F172A"/>
+                    </a:solidFill>
+                  </a:tcPr>
+                </a:tc>
+                <a:tc>
+                  <a:txBody>
+                    <a:bodyPr/>
+                    <a:lstStyle/>
+                    <a:p>
+                      <a:pPr>
+                        <a:defRPr sz="1050">
+                          <a:solidFill>
+                            <a:srgbClr val="FF3B30"/>
+                          </a:solidFill>
+                        </a:defRPr>
+                      </a:pPr>
+                      <a:r>
+                        <a:t>Hours spent manually filtering metadata.</a:t>
+                      </a:r>
+                    </a:p>
+                  </a:txBody>
+                  <a:tcPr>
+                    <a:solidFill>
+                      <a:srgbClr val="0F172A"/>
+                    </a:solidFill>
+                  </a:tcPr>
+                </a:tc>
+                <a:tc>
+                  <a:txBody>
+                    <a:bodyPr/>
+                    <a:lstStyle/>
+                    <a:p>
+                      <a:pPr>
+                        <a:defRPr sz="1050" b="1">
+                          <a:solidFill>
+                            <a:srgbClr val="34C759"/>
+                          </a:solidFill>
+                        </a:defRPr>
+                      </a:pPr>
+                      <a:r>
+                        <a:t>&lt; 85 ms semantic instant search.</a:t>
+                      </a:r>
+                    </a:p>
+                  </a:txBody>
+                  <a:tcPr>
+                    <a:solidFill>
+                      <a:srgbClr val="0F172A"/>
+                    </a:solidFill>
+                  </a:tcPr>
+                </a:tc>
+              </a:tr>
+              <a:tr h="932688">
+                <a:tc>
+                  <a:txBody>
+                    <a:bodyPr/>
+                    <a:lstStyle/>
+                    <a:p>
+                      <a:pPr>
+                        <a:defRPr sz="1050">
+                          <a:solidFill>
+                            <a:srgbClr val="FFFFFF"/>
+                          </a:solidFill>
+                        </a:defRPr>
+                      </a:pPr>
+                      <a:r>
+                        <a:t>False Alarm Fatigue</a:t>
+                      </a:r>
+                    </a:p>
+                  </a:txBody>
+                  <a:tcPr>
+                    <a:solidFill>
+                      <a:srgbClr val="0F172A"/>
+                    </a:solidFill>
+                  </a:tcPr>
+                </a:tc>
+                <a:tc>
+                  <a:txBody>
+                    <a:bodyPr/>
+                    <a:lstStyle/>
+                    <a:p>
+                      <a:pPr>
+                        <a:defRPr sz="1050">
+                          <a:solidFill>
+                            <a:srgbClr val="FF3B30"/>
+                          </a:solidFill>
+                        </a:defRPr>
+                      </a:pPr>
+                      <a:r>
+                        <a:t>70%+ false alarms from clouds &amp; seasons.</a:t>
+                      </a:r>
+                    </a:p>
+                  </a:txBody>
+                  <a:tcPr>
+                    <a:solidFill>
+                      <a:srgbClr val="0F172A"/>
+                    </a:solidFill>
+                  </a:tcPr>
+                </a:tc>
+                <a:tc>
+                  <a:txBody>
+                    <a:bodyPr/>
+                    <a:lstStyle/>
+                    <a:p>
+                      <a:pPr>
+                        <a:defRPr sz="1050" b="1">
+                          <a:solidFill>
+                            <a:srgbClr val="34C759"/>
+                          </a:solidFill>
+                        </a:defRPr>
+                      </a:pPr>
+                      <a:r>
+                        <a:t>93%+ false-alarm suppression rate.</a:t>
+                      </a:r>
+                    </a:p>
+                  </a:txBody>
+                  <a:tcPr>
+                    <a:solidFill>
+                      <a:srgbClr val="0F172A"/>
+                    </a:solidFill>
+                  </a:tcPr>
+                </a:tc>
+              </a:tr>
+              <a:tr h="932688">
+                <a:tc>
+                  <a:txBody>
+                    <a:bodyPr/>
+                    <a:lstStyle/>
+                    <a:p>
+                      <a:pPr>
+                        <a:defRPr sz="1050">
+                          <a:solidFill>
+                            <a:srgbClr val="FFFFFF"/>
+                          </a:solidFill>
+                        </a:defRPr>
+                      </a:pPr>
+                      <a:r>
+                        <a:t>Temporal Resolution</a:t>
+                      </a:r>
+                    </a:p>
+                  </a:txBody>
+                  <a:tcPr>
+                    <a:solidFill>
+                      <a:srgbClr val="0F172A"/>
+                    </a:solidFill>
+                  </a:tcPr>
+                </a:tc>
+                <a:tc>
+                  <a:txBody>
+                    <a:bodyPr/>
+                    <a:lstStyle/>
+                    <a:p>
+                      <a:pPr>
+                        <a:defRPr sz="1050">
+                          <a:solidFill>
+                            <a:srgbClr val="FF3B30"/>
+                          </a:solidFill>
+                        </a:defRPr>
+                      </a:pPr>
+                      <a:r>
+                        <a:t>Pairwise before/after manual comparison.</a:t>
+                      </a:r>
+                    </a:p>
+                  </a:txBody>
+                  <a:tcPr>
+                    <a:solidFill>
+                      <a:srgbClr val="0F172A"/>
+                    </a:solidFill>
+                  </a:tcPr>
+                </a:tc>
+                <a:tc>
+                  <a:txBody>
+                    <a:bodyPr/>
+                    <a:lstStyle/>
+                    <a:p>
+                      <a:pPr>
+                        <a:defRPr sz="1050" b="1">
+                          <a:solidFill>
+                            <a:srgbClr val="34C759"/>
+                          </a:solidFill>
+                        </a:defRPr>
+                      </a:pPr>
+                      <a:r>
+                        <a:t>Multi-year trajectory onset pinpointing.</a:t>
+                      </a:r>
+                    </a:p>
+                  </a:txBody>
+                  <a:tcPr>
+                    <a:solidFill>
+                      <a:srgbClr val="0F172A"/>
+                    </a:solidFill>
+                  </a:tcPr>
+                </a:tc>
+              </a:tr>
+              <a:tr h="932688">
+                <a:tc>
+                  <a:txBody>
+                    <a:bodyPr/>
+                    <a:lstStyle/>
+                    <a:p>
+                      <a:pPr>
+                        <a:defRPr sz="1050">
+                          <a:solidFill>
+                            <a:srgbClr val="FFFFFF"/>
+                          </a:solidFill>
+                        </a:defRPr>
+                      </a:pPr>
+                      <a:r>
+                        <a:t>Evidence Dossier</a:t>
+                      </a:r>
+                    </a:p>
+                  </a:txBody>
+                  <a:tcPr>
+                    <a:solidFill>
+                      <a:srgbClr val="0F172A"/>
+                    </a:solidFill>
+                  </a:tcPr>
+                </a:tc>
+                <a:tc>
+                  <a:txBody>
+                    <a:bodyPr/>
+                    <a:lstStyle/>
+                    <a:p>
+                      <a:pPr>
+                        <a:defRPr sz="1050">
+                          <a:solidFill>
+                            <a:srgbClr val="FF3B30"/>
+                          </a:solidFill>
+                        </a:defRPr>
+                      </a:pPr>
+                      <a:r>
+                        <a:t>Manual copy-pasting &amp; screenshot reports.</a:t>
+                      </a:r>
+                    </a:p>
+                  </a:txBody>
+                  <a:tcPr>
+                    <a:solidFill>
+                      <a:srgbClr val="0F172A"/>
+                    </a:solidFill>
+                  </a:tcPr>
+                </a:tc>
+                <a:tc>
+                  <a:txBody>
+                    <a:bodyPr/>
+                    <a:lstStyle/>
+                    <a:p>
+                      <a:pPr>
+                        <a:defRPr sz="1050" b="1">
+                          <a:solidFill>
+                            <a:srgbClr val="34C759"/>
+                          </a:solidFill>
+                        </a:defRPr>
+                      </a:pPr>
+                      <a:r>
+                        <a:t>Hashed automated cryptographic dossier.</a:t>
+                      </a:r>
+                    </a:p>
+                  </a:txBody>
+                  <a:tcPr>
+                    <a:solidFill>
+                      <a:srgbClr val="0F172A"/>
+                    </a:solidFill>
+                  </a:tcPr>
+                </a:tc>
+              </a:tr>
+            </a:tbl>
+          </a:graphicData>
+        </a:graphic>
+      </p:graphicFrame>
+    </p:spTree>
+  </p:cSld>
+  <p:clrMapOvr>
+    <a:masterClrMapping/>
+  </p:clrMapOvr>
+</p:sld>
+</file>
+
+<file path=ppt/slides/slide13.xml><?xml version="1.0" encoding="utf-8"?>
+<p:sld xmlns:a="http://schemas.openxmlformats.org/drawingml/2006/main" xmlns:p="http://schemas.openxmlformats.org/presentationml/2006/main" xmlns:r="http://schemas.openxmlformats.org/officeDocument/2006/relationships">
+  <p:cSld>
+    <p:bg>
+      <p:bgPr>
+        <a:solidFill>
+          <a:srgbClr val="0B1120"/>
+        </a:solidFill>
+        <a:effectLst/>
+      </p:bgPr>
+    </p:bg>
+    <p:spTree>
+      <p:nvGrpSpPr>
+        <p:cNvPr id="1" name=""/>
+        <p:cNvGrpSpPr/>
+        <p:nvPr/>
+      </p:nvGrpSpPr>
+      <p:grpSpPr/>
+      <p:sp>
+        <p:nvSpPr>
+          <p:cNvPr id="2" name="TextBox 1"/>
+          <p:cNvSpPr txBox="1"/>
+          <p:nvPr/>
+        </p:nvSpPr>
+        <p:spPr>
+          <a:xfrm>
+            <a:off x="731520" y="365760"/>
+            <a:ext cx="10728655" cy="274320"/>
+          </a:xfrm>
+          <a:prstGeom prst="rect">
+            <a:avLst/>
+          </a:prstGeom>
+          <a:noFill/>
+        </p:spPr>
+        <p:txBody>
+          <a:bodyPr wrap="square">
+            <a:spAutoFit/>
+          </a:bodyPr>
+          <a:lstStyle/>
+          <a:p>
+            <a:pPr>
+              <a:defRPr sz="1000" b="1">
+                <a:solidFill>
+                  <a:srgbClr val="00D2FF"/>
+                </a:solidFill>
+                <a:latin typeface="Helvetica"/>
+              </a:defRPr>
+            </a:pPr>
+            <a:r>
+              <a:t>SIH 2026 PS 26227 | GEOSPATIAL INTELLIGENCE PLATFORM</a:t>
+            </a:r>
+          </a:p>
+        </p:txBody>
+      </p:sp>
+      <p:sp>
+        <p:nvSpPr>
+          <p:cNvPr id="3" name="TextBox 2"/>
+          <p:cNvSpPr txBox="1"/>
+          <p:nvPr/>
+        </p:nvSpPr>
+        <p:spPr>
+          <a:xfrm>
+            <a:off x="731520" y="594360"/>
+            <a:ext cx="10728655" cy="548640"/>
+          </a:xfrm>
+          <a:prstGeom prst="rect">
+            <a:avLst/>
+          </a:prstGeom>
+          <a:noFill/>
+        </p:spPr>
+        <p:txBody>
+          <a:bodyPr wrap="square">
+            <a:spAutoFit/>
+          </a:bodyPr>
+          <a:lstStyle/>
+          <a:p>
+            <a:pPr>
+              <a:defRPr sz="2200" b="1">
+                <a:solidFill>
+                  <a:srgbClr val="FFFFFF"/>
+                </a:solidFill>
+                <a:latin typeface="Helvetica"/>
+              </a:defRPr>
+            </a:pPr>
+            <a:r>
+              <a:t>Deployment Architecture &amp; Requirement Traceability Matrix</a:t>
             </a:r>
           </a:p>
         </p:txBody>
@@ -4321,816 +5689,6 @@
 </p:sld>
 </file>
 
-<file path=ppt/slides/slide11.xml><?xml version="1.0" encoding="utf-8"?>
-<p:sld xmlns:a="http://schemas.openxmlformats.org/drawingml/2006/main" xmlns:p="http://schemas.openxmlformats.org/presentationml/2006/main" xmlns:r="http://schemas.openxmlformats.org/officeDocument/2006/relationships">
-  <p:cSld>
-    <p:bg>
-      <p:bgPr>
-        <a:solidFill>
-          <a:srgbClr val="0B1120"/>
-        </a:solidFill>
-        <a:effectLst/>
-      </p:bgPr>
-    </p:bg>
-    <p:spTree>
-      <p:nvGrpSpPr>
-        <p:cNvPr id="1" name=""/>
-        <p:cNvGrpSpPr/>
-        <p:nvPr/>
-      </p:nvGrpSpPr>
-      <p:grpSpPr/>
-      <p:sp>
-        <p:nvSpPr>
-          <p:cNvPr id="2" name="TextBox 1"/>
-          <p:cNvSpPr txBox="1"/>
-          <p:nvPr/>
-        </p:nvSpPr>
-        <p:spPr>
-          <a:xfrm>
-            <a:off x="731520" y="365760"/>
-            <a:ext cx="10728655" cy="274320"/>
-          </a:xfrm>
-          <a:prstGeom prst="rect">
-            <a:avLst/>
-          </a:prstGeom>
-          <a:noFill/>
-        </p:spPr>
-        <p:txBody>
-          <a:bodyPr wrap="square">
-            <a:spAutoFit/>
-          </a:bodyPr>
-          <a:lstStyle/>
-          <a:p>
-            <a:pPr>
-              <a:defRPr sz="1000" b="1">
-                <a:solidFill>
-                  <a:srgbClr val="00D2FF"/>
-                </a:solidFill>
-                <a:latin typeface="Helvetica"/>
-              </a:defRPr>
-            </a:pPr>
-            <a:r>
-              <a:t>TECHNICAL DEEP DIVE</a:t>
-            </a:r>
-          </a:p>
-        </p:txBody>
-      </p:sp>
-      <p:sp>
-        <p:nvSpPr>
-          <p:cNvPr id="3" name="TextBox 2"/>
-          <p:cNvSpPr txBox="1"/>
-          <p:nvPr/>
-        </p:nvSpPr>
-        <p:spPr>
-          <a:xfrm>
-            <a:off x="731520" y="594360"/>
-            <a:ext cx="10728655" cy="548640"/>
-          </a:xfrm>
-          <a:prstGeom prst="rect">
-            <a:avLst/>
-          </a:prstGeom>
-          <a:noFill/>
-        </p:spPr>
-        <p:txBody>
-          <a:bodyPr wrap="square">
-            <a:spAutoFit/>
-          </a:bodyPr>
-          <a:lstStyle/>
-          <a:p>
-            <a:pPr>
-              <a:defRPr sz="2200" b="1">
-                <a:solidFill>
-                  <a:srgbClr val="FFFFFF"/>
-                </a:solidFill>
-                <a:latin typeface="Helvetica"/>
-              </a:defRPr>
-            </a:pPr>
-            <a:r>
-              <a:t>Backup 1: Ingestion &amp; Preprocessing Architecture</a:t>
-            </a:r>
-          </a:p>
-        </p:txBody>
-      </p:sp>
-      <p:sp>
-        <p:nvSpPr>
-          <p:cNvPr id="4" name="Rounded Rectangle 3"/>
-          <p:cNvSpPr/>
-          <p:nvPr/>
-        </p:nvSpPr>
-        <p:spPr>
-          <a:xfrm>
-            <a:off x="731520" y="1280160"/>
-            <a:ext cx="10728655" cy="5029200"/>
-          </a:xfrm>
-          <a:prstGeom prst="roundRect">
-            <a:avLst/>
-          </a:prstGeom>
-          <a:solidFill>
-            <a:srgbClr val="0F172A"/>
-          </a:solidFill>
-          <a:ln w="19050">
-            <a:solidFill>
-              <a:srgbClr val="007AFF"/>
-            </a:solidFill>
-          </a:ln>
-        </p:spPr>
-        <p:style>
-          <a:lnRef idx="1">
-            <a:schemeClr val="accent1"/>
-          </a:lnRef>
-          <a:fillRef idx="3">
-            <a:schemeClr val="accent1"/>
-          </a:fillRef>
-          <a:effectRef idx="2">
-            <a:schemeClr val="accent1"/>
-          </a:effectRef>
-          <a:fontRef idx="minor">
-            <a:schemeClr val="lt1"/>
-          </a:fontRef>
-        </p:style>
-        <p:txBody>
-          <a:bodyPr rtlCol="0" anchor="ctr"/>
-          <a:lstStyle/>
-          <a:p>
-            <a:pPr algn="ctr"/>
-          </a:p>
-        </p:txBody>
-      </p:sp>
-      <p:sp>
-        <p:nvSpPr>
-          <p:cNvPr id="5" name="TextBox 4"/>
-          <p:cNvSpPr txBox="1"/>
-          <p:nvPr/>
-        </p:nvSpPr>
-        <p:spPr>
-          <a:xfrm>
-            <a:off x="914400" y="1463040"/>
-            <a:ext cx="10362895" cy="4663440"/>
-          </a:xfrm>
-          <a:prstGeom prst="rect">
-            <a:avLst/>
-          </a:prstGeom>
-          <a:noFill/>
-        </p:spPr>
-        <p:txBody>
-          <a:bodyPr wrap="square">
-            <a:spAutoFit/>
-          </a:bodyPr>
-          <a:lstStyle/>
-          <a:p>
-            <a:pPr>
-              <a:defRPr sz="1400" b="1">
-                <a:solidFill>
-                  <a:srgbClr val="00D2FF"/>
-                </a:solidFill>
-              </a:defRPr>
-            </a:pPr>
-            <a:r>
-              <a:t>DATA INGESTION &amp; QUALITY PIPELINE</a:t>
-            </a:r>
-          </a:p>
-          <a:p>
-            <a:pPr>
-              <a:spcAft>
-                <a:spcPts val="1200"/>
-              </a:spcAft>
-              <a:defRPr b="1" sz="1200">
-                <a:solidFill>
-                  <a:srgbClr val="00D2FF"/>
-                </a:solidFill>
-              </a:defRPr>
-            </a:pPr>
-            <a:r>
-              <a:t>• GeoTIFF &amp; COG Parsing: </a:t>
-            </a:r>
-            <a:r>
-              <a:rPr b="0">
-                <a:solidFill>
-                  <a:srgbClr val="FFFFFF"/>
-                </a:solidFill>
-              </a:rPr>
-              <a:t>Uses Rasterio &amp; GDAL for cloud-optimized GeoTIFF ingestion, extracting multi-spectral bands (B2, B3, B4, B8, B11, B12).</a:t>
-            </a:r>
-          </a:p>
-          <a:p>
-            <a:pPr>
-              <a:spcAft>
-                <a:spcPts val="1200"/>
-              </a:spcAft>
-              <a:defRPr b="1" sz="1200">
-                <a:solidFill>
-                  <a:srgbClr val="00D2FF"/>
-                </a:solidFill>
-              </a:defRPr>
-            </a:pPr>
-            <a:r>
-              <a:t>• STAC Metadata Cataloging: </a:t>
-            </a:r>
-            <a:r>
-              <a:rPr b="0">
-                <a:solidFill>
-                  <a:srgbClr val="FFFFFF"/>
-                </a:solidFill>
-              </a:rPr>
-              <a:t>Populates spatio-temporal asset catalog with cloud cover percentage, sun azimuth, and acquisition timestamps.</a:t>
-            </a:r>
-          </a:p>
-          <a:p>
-            <a:pPr>
-              <a:spcAft>
-                <a:spcPts val="1200"/>
-              </a:spcAft>
-              <a:defRPr b="1" sz="1200">
-                <a:solidFill>
-                  <a:srgbClr val="00D2FF"/>
-                </a:solidFill>
-              </a:defRPr>
-            </a:pPr>
-            <a:r>
-              <a:t>• Atmospheric Correction &amp; QA Masking: </a:t>
-            </a:r>
-            <a:r>
-              <a:rPr b="0">
-                <a:solidFill>
-                  <a:srgbClr val="FFFFFF"/>
-                </a:solidFill>
-              </a:rPr>
-              <a:t>Applies Scene Classification Layer (SCL) to flag clouds, cirrus, snow, and water shadows.</a:t>
-            </a:r>
-          </a:p>
-          <a:p>
-            <a:pPr>
-              <a:spcAft>
-                <a:spcPts val="1200"/>
-              </a:spcAft>
-              <a:defRPr b="1" sz="1200">
-                <a:solidFill>
-                  <a:srgbClr val="00D2FF"/>
-                </a:solidFill>
-              </a:defRPr>
-            </a:pPr>
-            <a:r>
-              <a:t>• Tiling &amp; Spatial Reprojection: </a:t>
-            </a:r>
-            <a:r>
-              <a:rPr b="0">
-                <a:solidFill>
-                  <a:srgbClr val="FFFFFF"/>
-                </a:solidFill>
-              </a:rPr>
-              <a:t>Reprojects imagery to UTM / EPSG:4326 and generates standardized 256x256 pixel spatial tiles.</a:t>
-            </a:r>
-          </a:p>
-        </p:txBody>
-      </p:sp>
-    </p:spTree>
-  </p:cSld>
-  <p:clrMapOvr>
-    <a:masterClrMapping/>
-  </p:clrMapOvr>
-</p:sld>
-</file>
-
-<file path=ppt/slides/slide12.xml><?xml version="1.0" encoding="utf-8"?>
-<p:sld xmlns:a="http://schemas.openxmlformats.org/drawingml/2006/main" xmlns:p="http://schemas.openxmlformats.org/presentationml/2006/main" xmlns:r="http://schemas.openxmlformats.org/officeDocument/2006/relationships">
-  <p:cSld>
-    <p:bg>
-      <p:bgPr>
-        <a:solidFill>
-          <a:srgbClr val="0B1120"/>
-        </a:solidFill>
-        <a:effectLst/>
-      </p:bgPr>
-    </p:bg>
-    <p:spTree>
-      <p:nvGrpSpPr>
-        <p:cNvPr id="1" name=""/>
-        <p:cNvGrpSpPr/>
-        <p:nvPr/>
-      </p:nvGrpSpPr>
-      <p:grpSpPr/>
-      <p:sp>
-        <p:nvSpPr>
-          <p:cNvPr id="2" name="TextBox 1"/>
-          <p:cNvSpPr txBox="1"/>
-          <p:nvPr/>
-        </p:nvSpPr>
-        <p:spPr>
-          <a:xfrm>
-            <a:off x="731520" y="365760"/>
-            <a:ext cx="10728655" cy="274320"/>
-          </a:xfrm>
-          <a:prstGeom prst="rect">
-            <a:avLst/>
-          </a:prstGeom>
-          <a:noFill/>
-        </p:spPr>
-        <p:txBody>
-          <a:bodyPr wrap="square">
-            <a:spAutoFit/>
-          </a:bodyPr>
-          <a:lstStyle/>
-          <a:p>
-            <a:pPr>
-              <a:defRPr sz="1000" b="1">
-                <a:solidFill>
-                  <a:srgbClr val="00D2FF"/>
-                </a:solidFill>
-                <a:latin typeface="Helvetica"/>
-              </a:defRPr>
-            </a:pPr>
-            <a:r>
-              <a:t>TECHNICAL DEEP DIVE</a:t>
-            </a:r>
-          </a:p>
-        </p:txBody>
-      </p:sp>
-      <p:sp>
-        <p:nvSpPr>
-          <p:cNvPr id="3" name="TextBox 2"/>
-          <p:cNvSpPr txBox="1"/>
-          <p:nvPr/>
-        </p:nvSpPr>
-        <p:spPr>
-          <a:xfrm>
-            <a:off x="731520" y="594360"/>
-            <a:ext cx="10728655" cy="548640"/>
-          </a:xfrm>
-          <a:prstGeom prst="rect">
-            <a:avLst/>
-          </a:prstGeom>
-          <a:noFill/>
-        </p:spPr>
-        <p:txBody>
-          <a:bodyPr wrap="square">
-            <a:spAutoFit/>
-          </a:bodyPr>
-          <a:lstStyle/>
-          <a:p>
-            <a:pPr>
-              <a:defRPr sz="2200" b="1">
-                <a:solidFill>
-                  <a:srgbClr val="FFFFFF"/>
-                </a:solidFill>
-                <a:latin typeface="Helvetica"/>
-              </a:defRPr>
-            </a:pPr>
-            <a:r>
-              <a:t>Backup 2: Multimodal Embedding &amp; Vector Search Mechanics</a:t>
-            </a:r>
-          </a:p>
-        </p:txBody>
-      </p:sp>
-      <p:sp>
-        <p:nvSpPr>
-          <p:cNvPr id="4" name="Rounded Rectangle 3"/>
-          <p:cNvSpPr/>
-          <p:nvPr/>
-        </p:nvSpPr>
-        <p:spPr>
-          <a:xfrm>
-            <a:off x="731520" y="1280160"/>
-            <a:ext cx="10728655" cy="5029200"/>
-          </a:xfrm>
-          <a:prstGeom prst="roundRect">
-            <a:avLst/>
-          </a:prstGeom>
-          <a:solidFill>
-            <a:srgbClr val="0F172A"/>
-          </a:solidFill>
-          <a:ln w="19050">
-            <a:solidFill>
-              <a:srgbClr val="007AFF"/>
-            </a:solidFill>
-          </a:ln>
-        </p:spPr>
-        <p:style>
-          <a:lnRef idx="1">
-            <a:schemeClr val="accent1"/>
-          </a:lnRef>
-          <a:fillRef idx="3">
-            <a:schemeClr val="accent1"/>
-          </a:fillRef>
-          <a:effectRef idx="2">
-            <a:schemeClr val="accent1"/>
-          </a:effectRef>
-          <a:fontRef idx="minor">
-            <a:schemeClr val="lt1"/>
-          </a:fontRef>
-        </p:style>
-        <p:txBody>
-          <a:bodyPr rtlCol="0" anchor="ctr"/>
-          <a:lstStyle/>
-          <a:p>
-            <a:pPr algn="ctr"/>
-          </a:p>
-        </p:txBody>
-      </p:sp>
-      <p:sp>
-        <p:nvSpPr>
-          <p:cNvPr id="5" name="TextBox 4"/>
-          <p:cNvSpPr txBox="1"/>
-          <p:nvPr/>
-        </p:nvSpPr>
-        <p:spPr>
-          <a:xfrm>
-            <a:off x="914400" y="1463040"/>
-            <a:ext cx="10362895" cy="4663440"/>
-          </a:xfrm>
-          <a:prstGeom prst="rect">
-            <a:avLst/>
-          </a:prstGeom>
-          <a:noFill/>
-        </p:spPr>
-        <p:txBody>
-          <a:bodyPr wrap="square">
-            <a:spAutoFit/>
-          </a:bodyPr>
-          <a:lstStyle/>
-          <a:p>
-            <a:pPr>
-              <a:defRPr sz="1400" b="1">
-                <a:solidFill>
-                  <a:srgbClr val="00D2FF"/>
-                </a:solidFill>
-              </a:defRPr>
-            </a:pPr>
-            <a:r>
-              <a:t>VISION-LANGUAGE MODEL (VLM) &amp; VECTOR SEARCH</a:t>
-            </a:r>
-          </a:p>
-          <a:p>
-            <a:pPr>
-              <a:spcAft>
-                <a:spcPts val="1200"/>
-              </a:spcAft>
-              <a:defRPr b="1" sz="1200">
-                <a:solidFill>
-                  <a:srgbClr val="00D2FF"/>
-                </a:solidFill>
-              </a:defRPr>
-            </a:pPr>
-            <a:r>
-              <a:t>• VLM Architecture: </a:t>
-            </a:r>
-            <a:r>
-              <a:rPr b="0">
-                <a:solidFill>
-                  <a:srgbClr val="FFFFFF"/>
-                </a:solidFill>
-              </a:rPr>
-              <a:t>Utilizes OpenCLIP / RemoteCLIP Transformer backbone trained on satellite-text pairs to embed tiles into 512-dimensional feature space.</a:t>
-            </a:r>
-          </a:p>
-          <a:p>
-            <a:pPr>
-              <a:spcAft>
-                <a:spcPts val="1200"/>
-              </a:spcAft>
-              <a:defRPr b="1" sz="1200">
-                <a:solidFill>
-                  <a:srgbClr val="00D2FF"/>
-                </a:solidFill>
-              </a:defRPr>
-            </a:pPr>
-            <a:r>
-              <a:t>• Vector Search Engine: </a:t>
-            </a:r>
-            <a:r>
-              <a:rPr b="0">
-                <a:solidFill>
-                  <a:srgbClr val="FFFFFF"/>
-                </a:solidFill>
-              </a:rPr>
-              <a:t>Employs high-performance vector indexing with Cosine Similarity and L2 distance metrics for sub-100ms response.</a:t>
-            </a:r>
-          </a:p>
-          <a:p>
-            <a:pPr>
-              <a:spcAft>
-                <a:spcPts val="1200"/>
-              </a:spcAft>
-              <a:defRPr b="1" sz="1200">
-                <a:solidFill>
-                  <a:srgbClr val="00D2FF"/>
-                </a:solidFill>
-              </a:defRPr>
-            </a:pPr>
-            <a:r>
-              <a:t>• Multimodal Similarity Formulation: </a:t>
-            </a:r>
-            <a:r>
-              <a:rPr b="0">
-                <a:solidFill>
-                  <a:srgbClr val="FFFFFF"/>
-                </a:solidFill>
-              </a:rPr>
-              <a:t>Sim(Text, Tile) = (E_text • E_tile) / (||E_text|| ||E_tile||)</a:t>
-            </a:r>
-          </a:p>
-          <a:p>
-            <a:pPr>
-              <a:spcAft>
-                <a:spcPts val="1200"/>
-              </a:spcAft>
-              <a:defRPr b="1" sz="1200">
-                <a:solidFill>
-                  <a:srgbClr val="00D2FF"/>
-                </a:solidFill>
-              </a:defRPr>
-            </a:pPr>
-            <a:r>
-              <a:t>• Incremental Vector Ingestion: </a:t>
-            </a:r>
-            <a:r>
-              <a:rPr b="0">
-                <a:solidFill>
-                  <a:srgbClr val="FFFFFF"/>
-                </a:solidFill>
-              </a:rPr>
-              <a:t>Appends new tile embeddings on the fly without needing full index rebuilds.</a:t>
-            </a:r>
-          </a:p>
-        </p:txBody>
-      </p:sp>
-    </p:spTree>
-  </p:cSld>
-  <p:clrMapOvr>
-    <a:masterClrMapping/>
-  </p:clrMapOvr>
-</p:sld>
-</file>
-
-<file path=ppt/slides/slide13.xml><?xml version="1.0" encoding="utf-8"?>
-<p:sld xmlns:a="http://schemas.openxmlformats.org/drawingml/2006/main" xmlns:p="http://schemas.openxmlformats.org/presentationml/2006/main" xmlns:r="http://schemas.openxmlformats.org/officeDocument/2006/relationships">
-  <p:cSld>
-    <p:bg>
-      <p:bgPr>
-        <a:solidFill>
-          <a:srgbClr val="0B1120"/>
-        </a:solidFill>
-        <a:effectLst/>
-      </p:bgPr>
-    </p:bg>
-    <p:spTree>
-      <p:nvGrpSpPr>
-        <p:cNvPr id="1" name=""/>
-        <p:cNvGrpSpPr/>
-        <p:nvPr/>
-      </p:nvGrpSpPr>
-      <p:grpSpPr/>
-      <p:sp>
-        <p:nvSpPr>
-          <p:cNvPr id="2" name="TextBox 1"/>
-          <p:cNvSpPr txBox="1"/>
-          <p:nvPr/>
-        </p:nvSpPr>
-        <p:spPr>
-          <a:xfrm>
-            <a:off x="731520" y="365760"/>
-            <a:ext cx="10728655" cy="274320"/>
-          </a:xfrm>
-          <a:prstGeom prst="rect">
-            <a:avLst/>
-          </a:prstGeom>
-          <a:noFill/>
-        </p:spPr>
-        <p:txBody>
-          <a:bodyPr wrap="square">
-            <a:spAutoFit/>
-          </a:bodyPr>
-          <a:lstStyle/>
-          <a:p>
-            <a:pPr>
-              <a:defRPr sz="1000" b="1">
-                <a:solidFill>
-                  <a:srgbClr val="00D2FF"/>
-                </a:solidFill>
-                <a:latin typeface="Helvetica"/>
-              </a:defRPr>
-            </a:pPr>
-            <a:r>
-              <a:t>TECHNICAL DEEP DIVE</a:t>
-            </a:r>
-          </a:p>
-        </p:txBody>
-      </p:sp>
-      <p:sp>
-        <p:nvSpPr>
-          <p:cNvPr id="3" name="TextBox 2"/>
-          <p:cNvSpPr txBox="1"/>
-          <p:nvPr/>
-        </p:nvSpPr>
-        <p:spPr>
-          <a:xfrm>
-            <a:off x="731520" y="594360"/>
-            <a:ext cx="10728655" cy="548640"/>
-          </a:xfrm>
-          <a:prstGeom prst="rect">
-            <a:avLst/>
-          </a:prstGeom>
-          <a:noFill/>
-        </p:spPr>
-        <p:txBody>
-          <a:bodyPr wrap="square">
-            <a:spAutoFit/>
-          </a:bodyPr>
-          <a:lstStyle/>
-          <a:p>
-            <a:pPr>
-              <a:defRPr sz="2200" b="1">
-                <a:solidFill>
-                  <a:srgbClr val="FFFFFF"/>
-                </a:solidFill>
-                <a:latin typeface="Helvetica"/>
-              </a:defRPr>
-            </a:pPr>
-            <a:r>
-              <a:t>Backup 3: Spectral Change Mathematics &amp; Trajectory Formulations</a:t>
-            </a:r>
-          </a:p>
-        </p:txBody>
-      </p:sp>
-      <p:sp>
-        <p:nvSpPr>
-          <p:cNvPr id="4" name="Rounded Rectangle 3"/>
-          <p:cNvSpPr/>
-          <p:nvPr/>
-        </p:nvSpPr>
-        <p:spPr>
-          <a:xfrm>
-            <a:off x="731520" y="1280160"/>
-            <a:ext cx="10728655" cy="5029200"/>
-          </a:xfrm>
-          <a:prstGeom prst="roundRect">
-            <a:avLst/>
-          </a:prstGeom>
-          <a:solidFill>
-            <a:srgbClr val="0F172A"/>
-          </a:solidFill>
-          <a:ln w="19050">
-            <a:solidFill>
-              <a:srgbClr val="007AFF"/>
-            </a:solidFill>
-          </a:ln>
-        </p:spPr>
-        <p:style>
-          <a:lnRef idx="1">
-            <a:schemeClr val="accent1"/>
-          </a:lnRef>
-          <a:fillRef idx="3">
-            <a:schemeClr val="accent1"/>
-          </a:fillRef>
-          <a:effectRef idx="2">
-            <a:schemeClr val="accent1"/>
-          </a:effectRef>
-          <a:fontRef idx="minor">
-            <a:schemeClr val="lt1"/>
-          </a:fontRef>
-        </p:style>
-        <p:txBody>
-          <a:bodyPr rtlCol="0" anchor="ctr"/>
-          <a:lstStyle/>
-          <a:p>
-            <a:pPr algn="ctr"/>
-          </a:p>
-        </p:txBody>
-      </p:sp>
-      <p:sp>
-        <p:nvSpPr>
-          <p:cNvPr id="5" name="TextBox 4"/>
-          <p:cNvSpPr txBox="1"/>
-          <p:nvPr/>
-        </p:nvSpPr>
-        <p:spPr>
-          <a:xfrm>
-            <a:off x="914400" y="1463040"/>
-            <a:ext cx="10362895" cy="4663440"/>
-          </a:xfrm>
-          <a:prstGeom prst="rect">
-            <a:avLst/>
-          </a:prstGeom>
-          <a:noFill/>
-        </p:spPr>
-        <p:txBody>
-          <a:bodyPr wrap="square">
-            <a:spAutoFit/>
-          </a:bodyPr>
-          <a:lstStyle/>
-          <a:p>
-            <a:pPr>
-              <a:defRPr sz="1400" b="1">
-                <a:solidFill>
-                  <a:srgbClr val="00D2FF"/>
-                </a:solidFill>
-              </a:defRPr>
-            </a:pPr>
-            <a:r>
-              <a:t>SPECTRAL FORMULATIONS &amp; CHANGE TRAJECTORIES</a:t>
-            </a:r>
-          </a:p>
-          <a:p>
-            <a:pPr>
-              <a:spcAft>
-                <a:spcPts val="1200"/>
-              </a:spcAft>
-              <a:defRPr b="1" sz="1200">
-                <a:solidFill>
-                  <a:srgbClr val="00D2FF"/>
-                </a:solidFill>
-              </a:defRPr>
-            </a:pPr>
-            <a:r>
-              <a:t>• Normalized Difference Vegetation Index (NDVI): </a:t>
-            </a:r>
-            <a:r>
-              <a:rPr b="0">
-                <a:solidFill>
-                  <a:srgbClr val="FFFFFF"/>
-                </a:solidFill>
-              </a:rPr>
-              <a:t>NDVI = (NIR - RED) / (NIR + RED)  -&gt; Tracks vegetation cover density.</a:t>
-            </a:r>
-          </a:p>
-          <a:p>
-            <a:pPr>
-              <a:spcAft>
-                <a:spcPts val="1200"/>
-              </a:spcAft>
-              <a:defRPr b="1" sz="1200">
-                <a:solidFill>
-                  <a:srgbClr val="00D2FF"/>
-                </a:solidFill>
-              </a:defRPr>
-            </a:pPr>
-            <a:r>
-              <a:t>• Normalized Difference Built-Up Index (NDBI): </a:t>
-            </a:r>
-            <a:r>
-              <a:rPr b="0">
-                <a:solidFill>
-                  <a:srgbClr val="FFFFFF"/>
-                </a:solidFill>
-              </a:rPr>
-              <a:t>NDBI = (SWIR - NIR) / (SWIR + NIR)  -&gt; Pinpoints artificial structures &amp; concrete.</a:t>
-            </a:r>
-          </a:p>
-          <a:p>
-            <a:pPr>
-              <a:spcAft>
-                <a:spcPts val="1200"/>
-              </a:spcAft>
-              <a:defRPr b="1" sz="1200">
-                <a:solidFill>
-                  <a:srgbClr val="00D2FF"/>
-                </a:solidFill>
-              </a:defRPr>
-            </a:pPr>
-            <a:r>
-              <a:t>• Normalized Difference Water Index (NDWI): </a:t>
-            </a:r>
-            <a:r>
-              <a:rPr b="0">
-                <a:solidFill>
-                  <a:srgbClr val="FFFFFF"/>
-                </a:solidFill>
-              </a:rPr>
-              <a:t>NDWI = (GREEN - NIR) / (GREEN + NIR) -&gt; Maps water body boundaries.</a:t>
-            </a:r>
-          </a:p>
-          <a:p>
-            <a:pPr>
-              <a:spcAft>
-                <a:spcPts val="1200"/>
-              </a:spcAft>
-              <a:defRPr b="1" sz="1200">
-                <a:solidFill>
-                  <a:srgbClr val="00D2FF"/>
-                </a:solidFill>
-              </a:defRPr>
-            </a:pPr>
-            <a:r>
-              <a:t>• Change Magnitude Delta: </a:t>
-            </a:r>
-            <a:r>
-              <a:rPr b="0">
-                <a:solidFill>
-                  <a:srgbClr val="FFFFFF"/>
-                </a:solidFill>
-              </a:rPr>
-              <a:t>Delta = sqrt((NDVI_after - NDVI_before)^2 + (NDBI_after - NDBI_before)^2)</a:t>
-            </a:r>
-          </a:p>
-        </p:txBody>
-      </p:sp>
-    </p:spTree>
-  </p:cSld>
-  <p:clrMapOvr>
-    <a:masterClrMapping/>
-  </p:clrMapOvr>
-</p:sld>
-</file>
-
 <file path=ppt/slides/slide14.xml><?xml version="1.0" encoding="utf-8"?>
 <p:sld xmlns:a="http://schemas.openxmlformats.org/drawingml/2006/main" xmlns:p="http://schemas.openxmlformats.org/presentationml/2006/main" xmlns:r="http://schemas.openxmlformats.org/officeDocument/2006/relationships">
   <p:cSld>
@@ -5216,7 +5774,7 @@
               </a:defRPr>
             </a:pPr>
             <a:r>
-              <a:t>Backup 4: False-Alarm Suppression Algorithms &amp; Noise Reduction</a:t>
+              <a:t>Backup 1: Ingestion &amp; Preprocessing Architecture</a:t>
             </a:r>
           </a:p>
         </p:txBody>
@@ -5296,7 +5854,7 @@
               </a:defRPr>
             </a:pPr>
             <a:r>
-              <a:t>ALGORITHMIC NOISE SUPPRESSION</a:t>
+              <a:t>DATA INGESTION &amp; QUALITY PIPELINE</a:t>
             </a:r>
           </a:p>
           <a:p>
@@ -5311,7 +5869,7 @@
               </a:defRPr>
             </a:pPr>
             <a:r>
-              <a:t>• Phenology Cycle Matching: </a:t>
+              <a:t>• GeoTIFF &amp; COG Parsing: </a:t>
             </a:r>
             <a:r>
               <a:rPr b="0">
@@ -5319,7 +5877,7 @@
                   <a:srgbClr val="FFFFFF"/>
                 </a:solidFill>
               </a:rPr>
-              <a:t>Compares same-month observations across consecutive years to cancel out annual agricultural cycles.</a:t>
+              <a:t>Uses Rasterio &amp; GDAL for cloud-optimized GeoTIFF ingestion, extracting multi-spectral bands (B2, B3, B4, B8, B11, B12).</a:t>
             </a:r>
           </a:p>
           <a:p>
@@ -5334,7 +5892,7 @@
               </a:defRPr>
             </a:pPr>
             <a:r>
-              <a:t>• Sub-Pixel Registration: </a:t>
+              <a:t>• STAC Metadata Cataloging: </a:t>
             </a:r>
             <a:r>
               <a:rPr b="0">
@@ -5342,7 +5900,7 @@
                   <a:srgbClr val="FFFFFF"/>
                 </a:solidFill>
               </a:rPr>
-              <a:t>Applies phase correlation to align multi-temporal scenes within 0.2 pixel margin, eliminating edge ringing.</a:t>
+              <a:t>Populates spatio-temporal asset catalog with cloud cover percentage, sun azimuth, and acquisition timestamps.</a:t>
             </a:r>
           </a:p>
           <a:p>
@@ -5357,7 +5915,7 @@
               </a:defRPr>
             </a:pPr>
             <a:r>
-              <a:t>• Temporal Persistence Filter: </a:t>
+              <a:t>• Atmospheric Correction &amp; QA Masking: </a:t>
             </a:r>
             <a:r>
               <a:rPr b="0">
@@ -5365,7 +5923,7 @@
                   <a:srgbClr val="FFFFFF"/>
                 </a:solidFill>
               </a:rPr>
-              <a:t>Change score must exceed threshold T across N &gt;= 3 consecutive observations to trigger alert.</a:t>
+              <a:t>Applies Scene Classification Layer (SCL) to flag clouds, cirrus, snow, and water shadows.</a:t>
             </a:r>
           </a:p>
           <a:p>
@@ -5380,7 +5938,7 @@
               </a:defRPr>
             </a:pPr>
             <a:r>
-              <a:t>• Spatial Context Morphology: </a:t>
+              <a:t>• Tiling &amp; Spatial Reprojection: </a:t>
             </a:r>
             <a:r>
               <a:rPr b="0">
@@ -5388,7 +5946,7 @@
                   <a:srgbClr val="FFFFFF"/>
                 </a:solidFill>
               </a:rPr>
-              <a:t>Applies opening/closing morphological operations to filter isolated pixel noise.</a:t>
+              <a:t>Reprojects imagery to UTM / EPSG:4326 and generates standardized 256x256 pixel spatial tiles.</a:t>
             </a:r>
           </a:p>
         </p:txBody>
@@ -5486,7 +6044,7 @@
               </a:defRPr>
             </a:pPr>
             <a:r>
-              <a:t>Backup 5: Air-Gapped Security &amp; Local Infrastructure</a:t>
+              <a:t>Backup 2: Multimodal Embedding &amp; Vector Search Mechanics</a:t>
             </a:r>
           </a:p>
         </p:txBody>
@@ -5566,7 +6124,7 @@
               </a:defRPr>
             </a:pPr>
             <a:r>
-              <a:t>SECURITY &amp; OPERATIONAL HARDENING</a:t>
+              <a:t>VISION-LANGUAGE MODEL (VLM) &amp; VECTOR SEARCH</a:t>
             </a:r>
           </a:p>
           <a:p>
@@ -5581,7 +6139,7 @@
               </a:defRPr>
             </a:pPr>
             <a:r>
-              <a:t>• Zero Network Dependency: </a:t>
+              <a:t>• VLM Architecture: </a:t>
             </a:r>
             <a:r>
               <a:rPr b="0">
@@ -5589,7 +6147,7 @@
                   <a:srgbClr val="FFFFFF"/>
                 </a:solidFill>
               </a:rPr>
-              <a:t>All model weights, indexes, and database assets reside locally inside isolated containers.</a:t>
+              <a:t>Utilizes OpenCLIP / RemoteCLIP Transformer backbone trained on satellite-text pairs to embed tiles into 512-dimensional feature space.</a:t>
             </a:r>
           </a:p>
           <a:p>
@@ -5604,7 +6162,7 @@
               </a:defRPr>
             </a:pPr>
             <a:r>
-              <a:t>• Resource Optimization: </a:t>
+              <a:t>• Vector Search Engine: </a:t>
             </a:r>
             <a:r>
               <a:rPr b="0">
@@ -5612,7 +6170,7 @@
                   <a:srgbClr val="FFFFFF"/>
                 </a:solidFill>
               </a:rPr>
-              <a:t>Runs efficiently on CPU workstations or GPU edge servers (NVIDIA Orin / RTX).</a:t>
+              <a:t>Employs high-performance vector indexing with Cosine Similarity and L2 distance metrics for sub-100ms response.</a:t>
             </a:r>
           </a:p>
           <a:p>
@@ -5627,7 +6185,7 @@
               </a:defRPr>
             </a:pPr>
             <a:r>
-              <a:t>• Role-Based Access Control: </a:t>
+              <a:t>• Multimodal Similarity Formulation: </a:t>
             </a:r>
             <a:r>
               <a:rPr b="0">
@@ -5635,7 +6193,7 @@
                   <a:srgbClr val="FFFFFF"/>
                 </a:solidFill>
               </a:rPr>
-              <a:t>Enforces local authentication and role-based permissions for analysts.</a:t>
+              <a:t>Sim(Text, Tile) = (E_text • E_tile) / (||E_text|| ||E_tile||)</a:t>
             </a:r>
           </a:p>
           <a:p>
@@ -5650,7 +6208,7 @@
               </a:defRPr>
             </a:pPr>
             <a:r>
-              <a:t>• Audit Provenance Logging: </a:t>
+              <a:t>• Incremental Vector Ingestion: </a:t>
             </a:r>
             <a:r>
               <a:rPr b="0">
@@ -5658,7 +6216,7 @@
                   <a:srgbClr val="FFFFFF"/>
                 </a:solidFill>
               </a:rPr>
-              <a:t>Generates SHA-256 hashed audit records for every search, query, and exported evidence dossier.</a:t>
+              <a:t>Appends new tile embeddings on the fly without needing full index rebuilds.</a:t>
             </a:r>
           </a:p>
         </p:txBody>
@@ -5756,7 +6314,7 @@
               </a:defRPr>
             </a:pPr>
             <a:r>
-              <a:t>Backup 6: Ground Truth Dataset &amp; Evaluation Framework</a:t>
+              <a:t>Backup 3: Spectral Change Mathematics &amp; Trajectory Formulations</a:t>
             </a:r>
           </a:p>
         </p:txBody>
@@ -5836,7 +6394,7 @@
               </a:defRPr>
             </a:pPr>
             <a:r>
-              <a:t>BENCHMARK DATASET &amp; EVALUATION METRICS</a:t>
+              <a:t>SPECTRAL FORMULATIONS &amp; CHANGE TRAJECTORIES</a:t>
             </a:r>
           </a:p>
           <a:p>
@@ -5851,7 +6409,7 @@
               </a:defRPr>
             </a:pPr>
             <a:r>
-              <a:t>• Annotated EO Evaluation Set: </a:t>
+              <a:t>• Normalized Difference Vegetation Index (NDVI): </a:t>
             </a:r>
             <a:r>
               <a:rPr b="0">
@@ -5859,7 +6417,7 @@
                   <a:srgbClr val="FFFFFF"/>
                 </a:solidFill>
               </a:rPr>
-              <a:t>500+ annotated Sentinel-2 multi-temporal scenes across diverse terrain (industrial, riverine, forest, coastal).</a:t>
+              <a:t>NDVI = (NIR - RED) / (NIR + RED)  -&gt; Tracks vegetation cover density.</a:t>
             </a:r>
           </a:p>
           <a:p>
@@ -5874,7 +6432,7 @@
               </a:defRPr>
             </a:pPr>
             <a:r>
-              <a:t>• Retrieval Performance Metrics: </a:t>
+              <a:t>• Normalized Difference Built-Up Index (NDBI): </a:t>
             </a:r>
             <a:r>
               <a:rPr b="0">
@@ -5882,7 +6440,7 @@
                   <a:srgbClr val="FFFFFF"/>
                 </a:solidFill>
               </a:rPr>
-              <a:t>Evaluated via Precision@K, Recall@K, Mean Reciprocal Rank (MRR), and nDCG@5.</a:t>
+              <a:t>NDBI = (SWIR - NIR) / (SWIR + NIR)  -&gt; Pinpoints artificial structures &amp; concrete.</a:t>
             </a:r>
           </a:p>
           <a:p>
@@ -5897,7 +6455,7 @@
               </a:defRPr>
             </a:pPr>
             <a:r>
-              <a:t>• Change Detection Metrics: </a:t>
+              <a:t>• Normalized Difference Water Index (NDWI): </a:t>
             </a:r>
             <a:r>
               <a:rPr b="0">
@@ -5905,7 +6463,7 @@
                   <a:srgbClr val="FFFFFF"/>
                 </a:solidFill>
               </a:rPr>
-              <a:t>Evaluated against human analyst annotations using IoU (Intersection over Union), F1-Score, and False Alarm Rate.</a:t>
+              <a:t>NDWI = (GREEN - NIR) / (GREEN + NIR) -&gt; Maps water body boundaries.</a:t>
             </a:r>
           </a:p>
           <a:p>
@@ -5920,7 +6478,7 @@
               </a:defRPr>
             </a:pPr>
             <a:r>
-              <a:t>• Latency &amp; System Profiling: </a:t>
+              <a:t>• Change Magnitude Delta: </a:t>
             </a:r>
             <a:r>
               <a:rPr b="0">
@@ -5928,7 +6486,7 @@
                   <a:srgbClr val="FFFFFF"/>
                 </a:solidFill>
               </a:rPr>
-              <a:t>Benchmarked query retrieval time, index build throughput, and memory footprint under multi-gigabyte loads.</a:t>
+              <a:t>Delta = sqrt((NDVI_after - NDVI_before)^2 + (NDBI_after - NDBI_before)^2)</a:t>
             </a:r>
           </a:p>
         </p:txBody>
@@ -5942,6 +6500,1302 @@
 </file>
 
 <file path=ppt/slides/slide17.xml><?xml version="1.0" encoding="utf-8"?>
+<p:sld xmlns:a="http://schemas.openxmlformats.org/drawingml/2006/main" xmlns:p="http://schemas.openxmlformats.org/presentationml/2006/main" xmlns:r="http://schemas.openxmlformats.org/officeDocument/2006/relationships">
+  <p:cSld>
+    <p:bg>
+      <p:bgPr>
+        <a:solidFill>
+          <a:srgbClr val="0B1120"/>
+        </a:solidFill>
+        <a:effectLst/>
+      </p:bgPr>
+    </p:bg>
+    <p:spTree>
+      <p:nvGrpSpPr>
+        <p:cNvPr id="1" name=""/>
+        <p:cNvGrpSpPr/>
+        <p:nvPr/>
+      </p:nvGrpSpPr>
+      <p:grpSpPr/>
+      <p:sp>
+        <p:nvSpPr>
+          <p:cNvPr id="2" name="TextBox 1"/>
+          <p:cNvSpPr txBox="1"/>
+          <p:nvPr/>
+        </p:nvSpPr>
+        <p:spPr>
+          <a:xfrm>
+            <a:off x="731520" y="365760"/>
+            <a:ext cx="10728655" cy="274320"/>
+          </a:xfrm>
+          <a:prstGeom prst="rect">
+            <a:avLst/>
+          </a:prstGeom>
+          <a:noFill/>
+        </p:spPr>
+        <p:txBody>
+          <a:bodyPr wrap="square">
+            <a:spAutoFit/>
+          </a:bodyPr>
+          <a:lstStyle/>
+          <a:p>
+            <a:pPr>
+              <a:defRPr sz="1000" b="1">
+                <a:solidFill>
+                  <a:srgbClr val="00D2FF"/>
+                </a:solidFill>
+                <a:latin typeface="Helvetica"/>
+              </a:defRPr>
+            </a:pPr>
+            <a:r>
+              <a:t>TECHNICAL DEEP DIVE</a:t>
+            </a:r>
+          </a:p>
+        </p:txBody>
+      </p:sp>
+      <p:sp>
+        <p:nvSpPr>
+          <p:cNvPr id="3" name="TextBox 2"/>
+          <p:cNvSpPr txBox="1"/>
+          <p:nvPr/>
+        </p:nvSpPr>
+        <p:spPr>
+          <a:xfrm>
+            <a:off x="731520" y="594360"/>
+            <a:ext cx="10728655" cy="548640"/>
+          </a:xfrm>
+          <a:prstGeom prst="rect">
+            <a:avLst/>
+          </a:prstGeom>
+          <a:noFill/>
+        </p:spPr>
+        <p:txBody>
+          <a:bodyPr wrap="square">
+            <a:spAutoFit/>
+          </a:bodyPr>
+          <a:lstStyle/>
+          <a:p>
+            <a:pPr>
+              <a:defRPr sz="2200" b="1">
+                <a:solidFill>
+                  <a:srgbClr val="FFFFFF"/>
+                </a:solidFill>
+                <a:latin typeface="Helvetica"/>
+              </a:defRPr>
+            </a:pPr>
+            <a:r>
+              <a:t>Backup 4: False-Alarm Suppression Algorithms &amp; Noise Reduction</a:t>
+            </a:r>
+          </a:p>
+        </p:txBody>
+      </p:sp>
+      <p:sp>
+        <p:nvSpPr>
+          <p:cNvPr id="4" name="Rounded Rectangle 3"/>
+          <p:cNvSpPr/>
+          <p:nvPr/>
+        </p:nvSpPr>
+        <p:spPr>
+          <a:xfrm>
+            <a:off x="731520" y="1280160"/>
+            <a:ext cx="10728655" cy="5029200"/>
+          </a:xfrm>
+          <a:prstGeom prst="roundRect">
+            <a:avLst/>
+          </a:prstGeom>
+          <a:solidFill>
+            <a:srgbClr val="0F172A"/>
+          </a:solidFill>
+          <a:ln w="19050">
+            <a:solidFill>
+              <a:srgbClr val="007AFF"/>
+            </a:solidFill>
+          </a:ln>
+        </p:spPr>
+        <p:style>
+          <a:lnRef idx="1">
+            <a:schemeClr val="accent1"/>
+          </a:lnRef>
+          <a:fillRef idx="3">
+            <a:schemeClr val="accent1"/>
+          </a:fillRef>
+          <a:effectRef idx="2">
+            <a:schemeClr val="accent1"/>
+          </a:effectRef>
+          <a:fontRef idx="minor">
+            <a:schemeClr val="lt1"/>
+          </a:fontRef>
+        </p:style>
+        <p:txBody>
+          <a:bodyPr rtlCol="0" anchor="ctr"/>
+          <a:lstStyle/>
+          <a:p>
+            <a:pPr algn="ctr"/>
+          </a:p>
+        </p:txBody>
+      </p:sp>
+      <p:sp>
+        <p:nvSpPr>
+          <p:cNvPr id="5" name="TextBox 4"/>
+          <p:cNvSpPr txBox="1"/>
+          <p:nvPr/>
+        </p:nvSpPr>
+        <p:spPr>
+          <a:xfrm>
+            <a:off x="914400" y="1463040"/>
+            <a:ext cx="10362895" cy="4663440"/>
+          </a:xfrm>
+          <a:prstGeom prst="rect">
+            <a:avLst/>
+          </a:prstGeom>
+          <a:noFill/>
+        </p:spPr>
+        <p:txBody>
+          <a:bodyPr wrap="square">
+            <a:spAutoFit/>
+          </a:bodyPr>
+          <a:lstStyle/>
+          <a:p>
+            <a:pPr>
+              <a:defRPr sz="1400" b="1">
+                <a:solidFill>
+                  <a:srgbClr val="00D2FF"/>
+                </a:solidFill>
+              </a:defRPr>
+            </a:pPr>
+            <a:r>
+              <a:t>ALGORITHMIC NOISE SUPPRESSION</a:t>
+            </a:r>
+          </a:p>
+          <a:p>
+            <a:pPr>
+              <a:spcAft>
+                <a:spcPts val="1200"/>
+              </a:spcAft>
+              <a:defRPr b="1" sz="1200">
+                <a:solidFill>
+                  <a:srgbClr val="00D2FF"/>
+                </a:solidFill>
+              </a:defRPr>
+            </a:pPr>
+            <a:r>
+              <a:t>• Phenology Cycle Matching: </a:t>
+            </a:r>
+            <a:r>
+              <a:rPr b="0">
+                <a:solidFill>
+                  <a:srgbClr val="FFFFFF"/>
+                </a:solidFill>
+              </a:rPr>
+              <a:t>Compares same-month observations across consecutive years to cancel out annual agricultural cycles.</a:t>
+            </a:r>
+          </a:p>
+          <a:p>
+            <a:pPr>
+              <a:spcAft>
+                <a:spcPts val="1200"/>
+              </a:spcAft>
+              <a:defRPr b="1" sz="1200">
+                <a:solidFill>
+                  <a:srgbClr val="00D2FF"/>
+                </a:solidFill>
+              </a:defRPr>
+            </a:pPr>
+            <a:r>
+              <a:t>• Sub-Pixel Registration: </a:t>
+            </a:r>
+            <a:r>
+              <a:rPr b="0">
+                <a:solidFill>
+                  <a:srgbClr val="FFFFFF"/>
+                </a:solidFill>
+              </a:rPr>
+              <a:t>Applies phase correlation to align multi-temporal scenes within 0.2 pixel margin, eliminating edge ringing.</a:t>
+            </a:r>
+          </a:p>
+          <a:p>
+            <a:pPr>
+              <a:spcAft>
+                <a:spcPts val="1200"/>
+              </a:spcAft>
+              <a:defRPr b="1" sz="1200">
+                <a:solidFill>
+                  <a:srgbClr val="00D2FF"/>
+                </a:solidFill>
+              </a:defRPr>
+            </a:pPr>
+            <a:r>
+              <a:t>• Temporal Persistence Filter: </a:t>
+            </a:r>
+            <a:r>
+              <a:rPr b="0">
+                <a:solidFill>
+                  <a:srgbClr val="FFFFFF"/>
+                </a:solidFill>
+              </a:rPr>
+              <a:t>Change score must exceed threshold T across N &gt;= 3 consecutive observations to trigger alert.</a:t>
+            </a:r>
+          </a:p>
+          <a:p>
+            <a:pPr>
+              <a:spcAft>
+                <a:spcPts val="1200"/>
+              </a:spcAft>
+              <a:defRPr b="1" sz="1200">
+                <a:solidFill>
+                  <a:srgbClr val="00D2FF"/>
+                </a:solidFill>
+              </a:defRPr>
+            </a:pPr>
+            <a:r>
+              <a:t>• Spatial Context Morphology: </a:t>
+            </a:r>
+            <a:r>
+              <a:rPr b="0">
+                <a:solidFill>
+                  <a:srgbClr val="FFFFFF"/>
+                </a:solidFill>
+              </a:rPr>
+              <a:t>Applies opening/closing morphological operations to filter isolated pixel noise.</a:t>
+            </a:r>
+          </a:p>
+        </p:txBody>
+      </p:sp>
+    </p:spTree>
+  </p:cSld>
+  <p:clrMapOvr>
+    <a:masterClrMapping/>
+  </p:clrMapOvr>
+</p:sld>
+</file>
+
+<file path=ppt/slides/slide18.xml><?xml version="1.0" encoding="utf-8"?>
+<p:sld xmlns:a="http://schemas.openxmlformats.org/drawingml/2006/main" xmlns:p="http://schemas.openxmlformats.org/presentationml/2006/main" xmlns:r="http://schemas.openxmlformats.org/officeDocument/2006/relationships">
+  <p:cSld>
+    <p:bg>
+      <p:bgPr>
+        <a:solidFill>
+          <a:srgbClr val="0B1120"/>
+        </a:solidFill>
+        <a:effectLst/>
+      </p:bgPr>
+    </p:bg>
+    <p:spTree>
+      <p:nvGrpSpPr>
+        <p:cNvPr id="1" name=""/>
+        <p:cNvGrpSpPr/>
+        <p:nvPr/>
+      </p:nvGrpSpPr>
+      <p:grpSpPr/>
+      <p:sp>
+        <p:nvSpPr>
+          <p:cNvPr id="2" name="TextBox 1"/>
+          <p:cNvSpPr txBox="1"/>
+          <p:nvPr/>
+        </p:nvSpPr>
+        <p:spPr>
+          <a:xfrm>
+            <a:off x="731520" y="365760"/>
+            <a:ext cx="10728655" cy="274320"/>
+          </a:xfrm>
+          <a:prstGeom prst="rect">
+            <a:avLst/>
+          </a:prstGeom>
+          <a:noFill/>
+        </p:spPr>
+        <p:txBody>
+          <a:bodyPr wrap="square">
+            <a:spAutoFit/>
+          </a:bodyPr>
+          <a:lstStyle/>
+          <a:p>
+            <a:pPr>
+              <a:defRPr sz="1000" b="1">
+                <a:solidFill>
+                  <a:srgbClr val="00D2FF"/>
+                </a:solidFill>
+                <a:latin typeface="Helvetica"/>
+              </a:defRPr>
+            </a:pPr>
+            <a:r>
+              <a:t>TECHNICAL DEEP DIVE</a:t>
+            </a:r>
+          </a:p>
+        </p:txBody>
+      </p:sp>
+      <p:sp>
+        <p:nvSpPr>
+          <p:cNvPr id="3" name="TextBox 2"/>
+          <p:cNvSpPr txBox="1"/>
+          <p:nvPr/>
+        </p:nvSpPr>
+        <p:spPr>
+          <a:xfrm>
+            <a:off x="731520" y="594360"/>
+            <a:ext cx="10728655" cy="548640"/>
+          </a:xfrm>
+          <a:prstGeom prst="rect">
+            <a:avLst/>
+          </a:prstGeom>
+          <a:noFill/>
+        </p:spPr>
+        <p:txBody>
+          <a:bodyPr wrap="square">
+            <a:spAutoFit/>
+          </a:bodyPr>
+          <a:lstStyle/>
+          <a:p>
+            <a:pPr>
+              <a:defRPr sz="2200" b="1">
+                <a:solidFill>
+                  <a:srgbClr val="FFFFFF"/>
+                </a:solidFill>
+                <a:latin typeface="Helvetica"/>
+              </a:defRPr>
+            </a:pPr>
+            <a:r>
+              <a:t>Backup 5: Air-Gapped Security &amp; Local Infrastructure</a:t>
+            </a:r>
+          </a:p>
+        </p:txBody>
+      </p:sp>
+      <p:sp>
+        <p:nvSpPr>
+          <p:cNvPr id="4" name="Rounded Rectangle 3"/>
+          <p:cNvSpPr/>
+          <p:nvPr/>
+        </p:nvSpPr>
+        <p:spPr>
+          <a:xfrm>
+            <a:off x="731520" y="1280160"/>
+            <a:ext cx="10728655" cy="5029200"/>
+          </a:xfrm>
+          <a:prstGeom prst="roundRect">
+            <a:avLst/>
+          </a:prstGeom>
+          <a:solidFill>
+            <a:srgbClr val="0F172A"/>
+          </a:solidFill>
+          <a:ln w="19050">
+            <a:solidFill>
+              <a:srgbClr val="007AFF"/>
+            </a:solidFill>
+          </a:ln>
+        </p:spPr>
+        <p:style>
+          <a:lnRef idx="1">
+            <a:schemeClr val="accent1"/>
+          </a:lnRef>
+          <a:fillRef idx="3">
+            <a:schemeClr val="accent1"/>
+          </a:fillRef>
+          <a:effectRef idx="2">
+            <a:schemeClr val="accent1"/>
+          </a:effectRef>
+          <a:fontRef idx="minor">
+            <a:schemeClr val="lt1"/>
+          </a:fontRef>
+        </p:style>
+        <p:txBody>
+          <a:bodyPr rtlCol="0" anchor="ctr"/>
+          <a:lstStyle/>
+          <a:p>
+            <a:pPr algn="ctr"/>
+          </a:p>
+        </p:txBody>
+      </p:sp>
+      <p:sp>
+        <p:nvSpPr>
+          <p:cNvPr id="5" name="TextBox 4"/>
+          <p:cNvSpPr txBox="1"/>
+          <p:nvPr/>
+        </p:nvSpPr>
+        <p:spPr>
+          <a:xfrm>
+            <a:off x="914400" y="1463040"/>
+            <a:ext cx="10362895" cy="4663440"/>
+          </a:xfrm>
+          <a:prstGeom prst="rect">
+            <a:avLst/>
+          </a:prstGeom>
+          <a:noFill/>
+        </p:spPr>
+        <p:txBody>
+          <a:bodyPr wrap="square">
+            <a:spAutoFit/>
+          </a:bodyPr>
+          <a:lstStyle/>
+          <a:p>
+            <a:pPr>
+              <a:defRPr sz="1400" b="1">
+                <a:solidFill>
+                  <a:srgbClr val="00D2FF"/>
+                </a:solidFill>
+              </a:defRPr>
+            </a:pPr>
+            <a:r>
+              <a:t>SECURITY &amp; OPERATIONAL HARDENING</a:t>
+            </a:r>
+          </a:p>
+          <a:p>
+            <a:pPr>
+              <a:spcAft>
+                <a:spcPts val="1200"/>
+              </a:spcAft>
+              <a:defRPr b="1" sz="1200">
+                <a:solidFill>
+                  <a:srgbClr val="00D2FF"/>
+                </a:solidFill>
+              </a:defRPr>
+            </a:pPr>
+            <a:r>
+              <a:t>• Zero Network Dependency: </a:t>
+            </a:r>
+            <a:r>
+              <a:rPr b="0">
+                <a:solidFill>
+                  <a:srgbClr val="FFFFFF"/>
+                </a:solidFill>
+              </a:rPr>
+              <a:t>All model weights, indexes, and database assets reside locally inside isolated containers.</a:t>
+            </a:r>
+          </a:p>
+          <a:p>
+            <a:pPr>
+              <a:spcAft>
+                <a:spcPts val="1200"/>
+              </a:spcAft>
+              <a:defRPr b="1" sz="1200">
+                <a:solidFill>
+                  <a:srgbClr val="00D2FF"/>
+                </a:solidFill>
+              </a:defRPr>
+            </a:pPr>
+            <a:r>
+              <a:t>• Resource Optimization: </a:t>
+            </a:r>
+            <a:r>
+              <a:rPr b="0">
+                <a:solidFill>
+                  <a:srgbClr val="FFFFFF"/>
+                </a:solidFill>
+              </a:rPr>
+              <a:t>Runs efficiently on CPU workstations or GPU edge servers (NVIDIA Orin / RTX).</a:t>
+            </a:r>
+          </a:p>
+          <a:p>
+            <a:pPr>
+              <a:spcAft>
+                <a:spcPts val="1200"/>
+              </a:spcAft>
+              <a:defRPr b="1" sz="1200">
+                <a:solidFill>
+                  <a:srgbClr val="00D2FF"/>
+                </a:solidFill>
+              </a:defRPr>
+            </a:pPr>
+            <a:r>
+              <a:t>• Role-Based Access Control: </a:t>
+            </a:r>
+            <a:r>
+              <a:rPr b="0">
+                <a:solidFill>
+                  <a:srgbClr val="FFFFFF"/>
+                </a:solidFill>
+              </a:rPr>
+              <a:t>Enforces local authentication and role-based permissions for analysts.</a:t>
+            </a:r>
+          </a:p>
+          <a:p>
+            <a:pPr>
+              <a:spcAft>
+                <a:spcPts val="1200"/>
+              </a:spcAft>
+              <a:defRPr b="1" sz="1200">
+                <a:solidFill>
+                  <a:srgbClr val="00D2FF"/>
+                </a:solidFill>
+              </a:defRPr>
+            </a:pPr>
+            <a:r>
+              <a:t>• Audit Provenance Logging: </a:t>
+            </a:r>
+            <a:r>
+              <a:rPr b="0">
+                <a:solidFill>
+                  <a:srgbClr val="FFFFFF"/>
+                </a:solidFill>
+              </a:rPr>
+              <a:t>Generates SHA-256 hashed audit records for every search, query, and exported evidence dossier.</a:t>
+            </a:r>
+          </a:p>
+        </p:txBody>
+      </p:sp>
+    </p:spTree>
+  </p:cSld>
+  <p:clrMapOvr>
+    <a:masterClrMapping/>
+  </p:clrMapOvr>
+</p:sld>
+</file>
+
+<file path=ppt/slides/slide19.xml><?xml version="1.0" encoding="utf-8"?>
+<p:sld xmlns:a="http://schemas.openxmlformats.org/drawingml/2006/main" xmlns:p="http://schemas.openxmlformats.org/presentationml/2006/main" xmlns:r="http://schemas.openxmlformats.org/officeDocument/2006/relationships">
+  <p:cSld>
+    <p:bg>
+      <p:bgPr>
+        <a:solidFill>
+          <a:srgbClr val="0B1120"/>
+        </a:solidFill>
+        <a:effectLst/>
+      </p:bgPr>
+    </p:bg>
+    <p:spTree>
+      <p:nvGrpSpPr>
+        <p:cNvPr id="1" name=""/>
+        <p:cNvGrpSpPr/>
+        <p:nvPr/>
+      </p:nvGrpSpPr>
+      <p:grpSpPr/>
+      <p:sp>
+        <p:nvSpPr>
+          <p:cNvPr id="2" name="TextBox 1"/>
+          <p:cNvSpPr txBox="1"/>
+          <p:nvPr/>
+        </p:nvSpPr>
+        <p:spPr>
+          <a:xfrm>
+            <a:off x="731520" y="365760"/>
+            <a:ext cx="10728655" cy="274320"/>
+          </a:xfrm>
+          <a:prstGeom prst="rect">
+            <a:avLst/>
+          </a:prstGeom>
+          <a:noFill/>
+        </p:spPr>
+        <p:txBody>
+          <a:bodyPr wrap="square">
+            <a:spAutoFit/>
+          </a:bodyPr>
+          <a:lstStyle/>
+          <a:p>
+            <a:pPr>
+              <a:defRPr sz="1000" b="1">
+                <a:solidFill>
+                  <a:srgbClr val="00D2FF"/>
+                </a:solidFill>
+                <a:latin typeface="Helvetica"/>
+              </a:defRPr>
+            </a:pPr>
+            <a:r>
+              <a:t>TECHNICAL DEEP DIVE</a:t>
+            </a:r>
+          </a:p>
+        </p:txBody>
+      </p:sp>
+      <p:sp>
+        <p:nvSpPr>
+          <p:cNvPr id="3" name="TextBox 2"/>
+          <p:cNvSpPr txBox="1"/>
+          <p:nvPr/>
+        </p:nvSpPr>
+        <p:spPr>
+          <a:xfrm>
+            <a:off x="731520" y="594360"/>
+            <a:ext cx="10728655" cy="548640"/>
+          </a:xfrm>
+          <a:prstGeom prst="rect">
+            <a:avLst/>
+          </a:prstGeom>
+          <a:noFill/>
+        </p:spPr>
+        <p:txBody>
+          <a:bodyPr wrap="square">
+            <a:spAutoFit/>
+          </a:bodyPr>
+          <a:lstStyle/>
+          <a:p>
+            <a:pPr>
+              <a:defRPr sz="2200" b="1">
+                <a:solidFill>
+                  <a:srgbClr val="FFFFFF"/>
+                </a:solidFill>
+                <a:latin typeface="Helvetica"/>
+              </a:defRPr>
+            </a:pPr>
+            <a:r>
+              <a:t>Backup 6: Ground Truth Dataset &amp; Evaluation Framework</a:t>
+            </a:r>
+          </a:p>
+        </p:txBody>
+      </p:sp>
+      <p:sp>
+        <p:nvSpPr>
+          <p:cNvPr id="4" name="Rounded Rectangle 3"/>
+          <p:cNvSpPr/>
+          <p:nvPr/>
+        </p:nvSpPr>
+        <p:spPr>
+          <a:xfrm>
+            <a:off x="731520" y="1280160"/>
+            <a:ext cx="10728655" cy="5029200"/>
+          </a:xfrm>
+          <a:prstGeom prst="roundRect">
+            <a:avLst/>
+          </a:prstGeom>
+          <a:solidFill>
+            <a:srgbClr val="0F172A"/>
+          </a:solidFill>
+          <a:ln w="19050">
+            <a:solidFill>
+              <a:srgbClr val="007AFF"/>
+            </a:solidFill>
+          </a:ln>
+        </p:spPr>
+        <p:style>
+          <a:lnRef idx="1">
+            <a:schemeClr val="accent1"/>
+          </a:lnRef>
+          <a:fillRef idx="3">
+            <a:schemeClr val="accent1"/>
+          </a:fillRef>
+          <a:effectRef idx="2">
+            <a:schemeClr val="accent1"/>
+          </a:effectRef>
+          <a:fontRef idx="minor">
+            <a:schemeClr val="lt1"/>
+          </a:fontRef>
+        </p:style>
+        <p:txBody>
+          <a:bodyPr rtlCol="0" anchor="ctr"/>
+          <a:lstStyle/>
+          <a:p>
+            <a:pPr algn="ctr"/>
+          </a:p>
+        </p:txBody>
+      </p:sp>
+      <p:sp>
+        <p:nvSpPr>
+          <p:cNvPr id="5" name="TextBox 4"/>
+          <p:cNvSpPr txBox="1"/>
+          <p:nvPr/>
+        </p:nvSpPr>
+        <p:spPr>
+          <a:xfrm>
+            <a:off x="914400" y="1463040"/>
+            <a:ext cx="10362895" cy="4663440"/>
+          </a:xfrm>
+          <a:prstGeom prst="rect">
+            <a:avLst/>
+          </a:prstGeom>
+          <a:noFill/>
+        </p:spPr>
+        <p:txBody>
+          <a:bodyPr wrap="square">
+            <a:spAutoFit/>
+          </a:bodyPr>
+          <a:lstStyle/>
+          <a:p>
+            <a:pPr>
+              <a:defRPr sz="1400" b="1">
+                <a:solidFill>
+                  <a:srgbClr val="00D2FF"/>
+                </a:solidFill>
+              </a:defRPr>
+            </a:pPr>
+            <a:r>
+              <a:t>BENCHMARK DATASET &amp; EVALUATION METRICS</a:t>
+            </a:r>
+          </a:p>
+          <a:p>
+            <a:pPr>
+              <a:spcAft>
+                <a:spcPts val="1200"/>
+              </a:spcAft>
+              <a:defRPr b="1" sz="1200">
+                <a:solidFill>
+                  <a:srgbClr val="00D2FF"/>
+                </a:solidFill>
+              </a:defRPr>
+            </a:pPr>
+            <a:r>
+              <a:t>• Annotated EO Evaluation Set: </a:t>
+            </a:r>
+            <a:r>
+              <a:rPr b="0">
+                <a:solidFill>
+                  <a:srgbClr val="FFFFFF"/>
+                </a:solidFill>
+              </a:rPr>
+              <a:t>500+ annotated Sentinel-2 multi-temporal scenes across diverse terrain (industrial, riverine, forest, coastal).</a:t>
+            </a:r>
+          </a:p>
+          <a:p>
+            <a:pPr>
+              <a:spcAft>
+                <a:spcPts val="1200"/>
+              </a:spcAft>
+              <a:defRPr b="1" sz="1200">
+                <a:solidFill>
+                  <a:srgbClr val="00D2FF"/>
+                </a:solidFill>
+              </a:defRPr>
+            </a:pPr>
+            <a:r>
+              <a:t>• Retrieval Performance Metrics: </a:t>
+            </a:r>
+            <a:r>
+              <a:rPr b="0">
+                <a:solidFill>
+                  <a:srgbClr val="FFFFFF"/>
+                </a:solidFill>
+              </a:rPr>
+              <a:t>Evaluated via Precision@K, Recall@K, Mean Reciprocal Rank (MRR), and nDCG@5.</a:t>
+            </a:r>
+          </a:p>
+          <a:p>
+            <a:pPr>
+              <a:spcAft>
+                <a:spcPts val="1200"/>
+              </a:spcAft>
+              <a:defRPr b="1" sz="1200">
+                <a:solidFill>
+                  <a:srgbClr val="00D2FF"/>
+                </a:solidFill>
+              </a:defRPr>
+            </a:pPr>
+            <a:r>
+              <a:t>• Change Detection Metrics: </a:t>
+            </a:r>
+            <a:r>
+              <a:rPr b="0">
+                <a:solidFill>
+                  <a:srgbClr val="FFFFFF"/>
+                </a:solidFill>
+              </a:rPr>
+              <a:t>Evaluated against human analyst annotations using IoU (Intersection over Union), F1-Score, and False Alarm Rate.</a:t>
+            </a:r>
+          </a:p>
+          <a:p>
+            <a:pPr>
+              <a:spcAft>
+                <a:spcPts val="1200"/>
+              </a:spcAft>
+              <a:defRPr b="1" sz="1200">
+                <a:solidFill>
+                  <a:srgbClr val="00D2FF"/>
+                </a:solidFill>
+              </a:defRPr>
+            </a:pPr>
+            <a:r>
+              <a:t>• Latency &amp; System Profiling: </a:t>
+            </a:r>
+            <a:r>
+              <a:rPr b="0">
+                <a:solidFill>
+                  <a:srgbClr val="FFFFFF"/>
+                </a:solidFill>
+              </a:rPr>
+              <a:t>Benchmarked query retrieval time, index build throughput, and memory footprint under multi-gigabyte loads.</a:t>
+            </a:r>
+          </a:p>
+        </p:txBody>
+      </p:sp>
+    </p:spTree>
+  </p:cSld>
+  <p:clrMapOvr>
+    <a:masterClrMapping/>
+  </p:clrMapOvr>
+</p:sld>
+</file>
+
+<file path=ppt/slides/slide2.xml><?xml version="1.0" encoding="utf-8"?>
+<p:sld xmlns:a="http://schemas.openxmlformats.org/drawingml/2006/main" xmlns:p="http://schemas.openxmlformats.org/presentationml/2006/main" xmlns:r="http://schemas.openxmlformats.org/officeDocument/2006/relationships">
+  <p:cSld>
+    <p:bg>
+      <p:bgPr>
+        <a:solidFill>
+          <a:srgbClr val="0B1120"/>
+        </a:solidFill>
+        <a:effectLst/>
+      </p:bgPr>
+    </p:bg>
+    <p:spTree>
+      <p:nvGrpSpPr>
+        <p:cNvPr id="1" name=""/>
+        <p:cNvGrpSpPr/>
+        <p:nvPr/>
+      </p:nvGrpSpPr>
+      <p:grpSpPr/>
+      <p:sp>
+        <p:nvSpPr>
+          <p:cNvPr id="2" name="TextBox 1"/>
+          <p:cNvSpPr txBox="1"/>
+          <p:nvPr/>
+        </p:nvSpPr>
+        <p:spPr>
+          <a:xfrm>
+            <a:off x="731520" y="365760"/>
+            <a:ext cx="10728655" cy="274320"/>
+          </a:xfrm>
+          <a:prstGeom prst="rect">
+            <a:avLst/>
+          </a:prstGeom>
+          <a:noFill/>
+        </p:spPr>
+        <p:txBody>
+          <a:bodyPr wrap="square">
+            <a:spAutoFit/>
+          </a:bodyPr>
+          <a:lstStyle/>
+          <a:p>
+            <a:pPr>
+              <a:defRPr sz="1000" b="1">
+                <a:solidFill>
+                  <a:srgbClr val="00D2FF"/>
+                </a:solidFill>
+                <a:latin typeface="Helvetica"/>
+              </a:defRPr>
+            </a:pPr>
+            <a:r>
+              <a:t>SIH 2026 PS 26227 | GEOSPATIAL INTELLIGENCE PLATFORM</a:t>
+            </a:r>
+          </a:p>
+        </p:txBody>
+      </p:sp>
+      <p:sp>
+        <p:nvSpPr>
+          <p:cNvPr id="3" name="TextBox 2"/>
+          <p:cNvSpPr txBox="1"/>
+          <p:nvPr/>
+        </p:nvSpPr>
+        <p:spPr>
+          <a:xfrm>
+            <a:off x="731520" y="594360"/>
+            <a:ext cx="10728655" cy="548640"/>
+          </a:xfrm>
+          <a:prstGeom prst="rect">
+            <a:avLst/>
+          </a:prstGeom>
+          <a:noFill/>
+        </p:spPr>
+        <p:txBody>
+          <a:bodyPr wrap="square">
+            <a:spAutoFit/>
+          </a:bodyPr>
+          <a:lstStyle/>
+          <a:p>
+            <a:pPr>
+              <a:defRPr sz="2200" b="1">
+                <a:solidFill>
+                  <a:srgbClr val="FFFFFF"/>
+                </a:solidFill>
+                <a:latin typeface="Helvetica"/>
+              </a:defRPr>
+            </a:pPr>
+            <a:r>
+              <a:t>Why Existing Satellite Workflows Break in Operations</a:t>
+            </a:r>
+          </a:p>
+        </p:txBody>
+      </p:sp>
+      <p:sp>
+        <p:nvSpPr>
+          <p:cNvPr id="4" name="Rounded Rectangle 3"/>
+          <p:cNvSpPr/>
+          <p:nvPr/>
+        </p:nvSpPr>
+        <p:spPr>
+          <a:xfrm>
+            <a:off x="731520" y="1371600"/>
+            <a:ext cx="5212080" cy="2286000"/>
+          </a:xfrm>
+          <a:prstGeom prst="roundRect">
+            <a:avLst/>
+          </a:prstGeom>
+          <a:solidFill>
+            <a:srgbClr val="0F172A"/>
+          </a:solidFill>
+          <a:ln w="19050">
+            <a:solidFill>
+              <a:srgbClr val="FF3B30"/>
+            </a:solidFill>
+          </a:ln>
+        </p:spPr>
+        <p:style>
+          <a:lnRef idx="1">
+            <a:schemeClr val="accent1"/>
+          </a:lnRef>
+          <a:fillRef idx="3">
+            <a:schemeClr val="accent1"/>
+          </a:fillRef>
+          <a:effectRef idx="2">
+            <a:schemeClr val="accent1"/>
+          </a:effectRef>
+          <a:fontRef idx="minor">
+            <a:schemeClr val="lt1"/>
+          </a:fontRef>
+        </p:style>
+        <p:txBody>
+          <a:bodyPr rtlCol="0" anchor="ctr"/>
+          <a:lstStyle/>
+          <a:p>
+            <a:pPr algn="ctr"/>
+          </a:p>
+        </p:txBody>
+      </p:sp>
+      <p:sp>
+        <p:nvSpPr>
+          <p:cNvPr id="5" name="TextBox 4"/>
+          <p:cNvSpPr txBox="1"/>
+          <p:nvPr/>
+        </p:nvSpPr>
+        <p:spPr>
+          <a:xfrm>
+            <a:off x="914400" y="1554480"/>
+            <a:ext cx="4846320" cy="1920240"/>
+          </a:xfrm>
+          <a:prstGeom prst="rect">
+            <a:avLst/>
+          </a:prstGeom>
+          <a:noFill/>
+        </p:spPr>
+        <p:txBody>
+          <a:bodyPr wrap="square">
+            <a:spAutoFit/>
+          </a:bodyPr>
+          <a:lstStyle/>
+          <a:p>
+            <a:pPr>
+              <a:defRPr sz="1300" b="1">
+                <a:solidFill>
+                  <a:srgbClr val="FF3B30"/>
+                </a:solidFill>
+              </a:defRPr>
+            </a:pPr>
+            <a:r>
+              <a:t>1. METADATA SEARCH GAP</a:t>
+            </a:r>
+          </a:p>
+          <a:p>
+            <a:pPr>
+              <a:defRPr sz="1100">
+                <a:solidFill>
+                  <a:srgbClr val="FFFFFF"/>
+                </a:solidFill>
+              </a:defRPr>
+            </a:pPr>
+            <a:r>
+              <a:t>Can answer: 'Show region X in 2024'</a:t>
+            </a:r>
+            <a:br/>
+            <a:r>
+              <a:t>Cannot answer: 'Show industrial expansion near river banks'</a:t>
+            </a:r>
+            <a:br/>
+            <a:r>
+              <a:t>Result: Hours spent manually sifting irrelevant scenes.</a:t>
+            </a:r>
+          </a:p>
+        </p:txBody>
+      </p:sp>
+      <p:sp>
+        <p:nvSpPr>
+          <p:cNvPr id="6" name="Rounded Rectangle 5"/>
+          <p:cNvSpPr/>
+          <p:nvPr/>
+        </p:nvSpPr>
+        <p:spPr>
+          <a:xfrm>
+            <a:off x="6172200" y="1371600"/>
+            <a:ext cx="5212080" cy="2286000"/>
+          </a:xfrm>
+          <a:prstGeom prst="roundRect">
+            <a:avLst/>
+          </a:prstGeom>
+          <a:solidFill>
+            <a:srgbClr val="0F172A"/>
+          </a:solidFill>
+          <a:ln w="19050">
+            <a:solidFill>
+              <a:srgbClr val="FF3B30"/>
+            </a:solidFill>
+          </a:ln>
+        </p:spPr>
+        <p:style>
+          <a:lnRef idx="1">
+            <a:schemeClr val="accent1"/>
+          </a:lnRef>
+          <a:fillRef idx="3">
+            <a:schemeClr val="accent1"/>
+          </a:fillRef>
+          <a:effectRef idx="2">
+            <a:schemeClr val="accent1"/>
+          </a:effectRef>
+          <a:fontRef idx="minor">
+            <a:schemeClr val="lt1"/>
+          </a:fontRef>
+        </p:style>
+        <p:txBody>
+          <a:bodyPr rtlCol="0" anchor="ctr"/>
+          <a:lstStyle/>
+          <a:p>
+            <a:pPr algn="ctr"/>
+          </a:p>
+        </p:txBody>
+      </p:sp>
+      <p:sp>
+        <p:nvSpPr>
+          <p:cNvPr id="7" name="TextBox 6"/>
+          <p:cNvSpPr txBox="1"/>
+          <p:nvPr/>
+        </p:nvSpPr>
+        <p:spPr>
+          <a:xfrm>
+            <a:off x="6355080" y="1554480"/>
+            <a:ext cx="4846320" cy="1920240"/>
+          </a:xfrm>
+          <a:prstGeom prst="rect">
+            <a:avLst/>
+          </a:prstGeom>
+          <a:noFill/>
+        </p:spPr>
+        <p:txBody>
+          <a:bodyPr wrap="square">
+            <a:spAutoFit/>
+          </a:bodyPr>
+          <a:lstStyle/>
+          <a:p>
+            <a:pPr>
+              <a:defRPr sz="1300" b="1">
+                <a:solidFill>
+                  <a:srgbClr val="FF3B30"/>
+                </a:solidFill>
+              </a:defRPr>
+            </a:pPr>
+            <a:r>
+              <a:t>2. NAIVE DIFFERENCE NOISE</a:t>
+            </a:r>
+          </a:p>
+          <a:p>
+            <a:pPr>
+              <a:defRPr sz="1100">
+                <a:solidFill>
+                  <a:srgbClr val="FFFFFF"/>
+                </a:solidFill>
+              </a:defRPr>
+            </a:pPr>
+            <a:r>
+              <a:t>Simple pairwise subtraction flags crop growth, cloud shadows, and seasonal phenology as major structural changes.</a:t>
+            </a:r>
+            <a:br/>
+            <a:r>
+              <a:t>Result: 70%+ analyst time wasted on false alarms.</a:t>
+            </a:r>
+          </a:p>
+        </p:txBody>
+      </p:sp>
+      <p:sp>
+        <p:nvSpPr>
+          <p:cNvPr id="8" name="Rounded Rectangle 7"/>
+          <p:cNvSpPr/>
+          <p:nvPr/>
+        </p:nvSpPr>
+        <p:spPr>
+          <a:xfrm>
+            <a:off x="731520" y="3840480"/>
+            <a:ext cx="5212080" cy="2286000"/>
+          </a:xfrm>
+          <a:prstGeom prst="roundRect">
+            <a:avLst/>
+          </a:prstGeom>
+          <a:solidFill>
+            <a:srgbClr val="0F172A"/>
+          </a:solidFill>
+          <a:ln w="19050">
+            <a:solidFill>
+              <a:srgbClr val="FF3B30"/>
+            </a:solidFill>
+          </a:ln>
+        </p:spPr>
+        <p:style>
+          <a:lnRef idx="1">
+            <a:schemeClr val="accent1"/>
+          </a:lnRef>
+          <a:fillRef idx="3">
+            <a:schemeClr val="accent1"/>
+          </a:fillRef>
+          <a:effectRef idx="2">
+            <a:schemeClr val="accent1"/>
+          </a:effectRef>
+          <a:fontRef idx="minor">
+            <a:schemeClr val="lt1"/>
+          </a:fontRef>
+        </p:style>
+        <p:txBody>
+          <a:bodyPr rtlCol="0" anchor="ctr"/>
+          <a:lstStyle/>
+          <a:p>
+            <a:pPr algn="ctr"/>
+          </a:p>
+        </p:txBody>
+      </p:sp>
+      <p:sp>
+        <p:nvSpPr>
+          <p:cNvPr id="9" name="TextBox 8"/>
+          <p:cNvSpPr txBox="1"/>
+          <p:nvPr/>
+        </p:nvSpPr>
+        <p:spPr>
+          <a:xfrm>
+            <a:off x="914400" y="4023360"/>
+            <a:ext cx="4846320" cy="1920240"/>
+          </a:xfrm>
+          <a:prstGeom prst="rect">
+            <a:avLst/>
+          </a:prstGeom>
+          <a:noFill/>
+        </p:spPr>
+        <p:txBody>
+          <a:bodyPr wrap="square">
+            <a:spAutoFit/>
+          </a:bodyPr>
+          <a:lstStyle/>
+          <a:p>
+            <a:pPr>
+              <a:defRPr sz="1300" b="1">
+                <a:solidFill>
+                  <a:srgbClr val="FF3B30"/>
+                </a:solidFill>
+              </a:defRPr>
+            </a:pPr>
+            <a:r>
+              <a:t>3. MANUAL TEMPORAL ANALYSIS</a:t>
+            </a:r>
+          </a:p>
+          <a:p>
+            <a:pPr>
+              <a:defRPr sz="1100">
+                <a:solidFill>
+                  <a:srgbClr val="FFFFFF"/>
+                </a:solidFill>
+              </a:defRPr>
+            </a:pPr>
+            <a:r>
+              <a:t>Comparing multi-year image stacks requires manually overlaying layers across dozens of acquisition dates.</a:t>
+            </a:r>
+            <a:br/>
+            <a:r>
+              <a:t>Result: Critical change onset dates missed.</a:t>
+            </a:r>
+          </a:p>
+        </p:txBody>
+      </p:sp>
+      <p:sp>
+        <p:nvSpPr>
+          <p:cNvPr id="10" name="Rounded Rectangle 9"/>
+          <p:cNvSpPr/>
+          <p:nvPr/>
+        </p:nvSpPr>
+        <p:spPr>
+          <a:xfrm>
+            <a:off x="6172200" y="3840480"/>
+            <a:ext cx="5212080" cy="2286000"/>
+          </a:xfrm>
+          <a:prstGeom prst="roundRect">
+            <a:avLst/>
+          </a:prstGeom>
+          <a:solidFill>
+            <a:srgbClr val="0F172A"/>
+          </a:solidFill>
+          <a:ln w="19050">
+            <a:solidFill>
+              <a:srgbClr val="FF3B30"/>
+            </a:solidFill>
+          </a:ln>
+        </p:spPr>
+        <p:style>
+          <a:lnRef idx="1">
+            <a:schemeClr val="accent1"/>
+          </a:lnRef>
+          <a:fillRef idx="3">
+            <a:schemeClr val="accent1"/>
+          </a:fillRef>
+          <a:effectRef idx="2">
+            <a:schemeClr val="accent1"/>
+          </a:effectRef>
+          <a:fontRef idx="minor">
+            <a:schemeClr val="lt1"/>
+          </a:fontRef>
+        </p:style>
+        <p:txBody>
+          <a:bodyPr rtlCol="0" anchor="ctr"/>
+          <a:lstStyle/>
+          <a:p>
+            <a:pPr algn="ctr"/>
+          </a:p>
+        </p:txBody>
+      </p:sp>
+      <p:sp>
+        <p:nvSpPr>
+          <p:cNvPr id="11" name="TextBox 10"/>
+          <p:cNvSpPr txBox="1"/>
+          <p:nvPr/>
+        </p:nvSpPr>
+        <p:spPr>
+          <a:xfrm>
+            <a:off x="6355080" y="4023360"/>
+            <a:ext cx="4846320" cy="1920240"/>
+          </a:xfrm>
+          <a:prstGeom prst="rect">
+            <a:avLst/>
+          </a:prstGeom>
+          <a:noFill/>
+        </p:spPr>
+        <p:txBody>
+          <a:bodyPr wrap="square">
+            <a:spAutoFit/>
+          </a:bodyPr>
+          <a:lstStyle/>
+          <a:p>
+            <a:pPr>
+              <a:defRPr sz="1300" b="1">
+                <a:solidFill>
+                  <a:srgbClr val="FF3B30"/>
+                </a:solidFill>
+              </a:defRPr>
+            </a:pPr>
+            <a:r>
+              <a:t>4. LACK OF PROVENANCE &amp; TRUST</a:t>
+            </a:r>
+          </a:p>
+          <a:p>
+            <a:pPr>
+              <a:defRPr sz="1100">
+                <a:solidFill>
+                  <a:srgbClr val="FFFFFF"/>
+                </a:solidFill>
+              </a:defRPr>
+            </a:pPr>
+            <a:r>
+              <a:t>Standalone deep learning models output raw bounding boxes without processing logs, metadata, or confidence scores.</a:t>
+            </a:r>
+            <a:br/>
+            <a:r>
+              <a:t>Result: Unverifiable intelligence.</a:t>
+            </a:r>
+          </a:p>
+        </p:txBody>
+      </p:sp>
+    </p:spTree>
+  </p:cSld>
+  <p:clrMapOvr>
+    <a:masterClrMapping/>
+  </p:clrMapOvr>
+</p:sld>
+</file>
+
+<file path=ppt/slides/slide20.xml><?xml version="1.0" encoding="utf-8"?>
 <p:sld xmlns:a="http://schemas.openxmlformats.org/drawingml/2006/main" xmlns:p="http://schemas.openxmlformats.org/presentationml/2006/main" xmlns:r="http://schemas.openxmlformats.org/officeDocument/2006/relationships">
   <p:cSld>
     <p:bg>
@@ -6679,7 +8533,7 @@
 </p:sld>
 </file>
 
-<file path=ppt/slides/slide18.xml><?xml version="1.0" encoding="utf-8"?>
+<file path=ppt/slides/slide21.xml><?xml version="1.0" encoding="utf-8"?>
 <p:sld xmlns:a="http://schemas.openxmlformats.org/drawingml/2006/main" xmlns:p="http://schemas.openxmlformats.org/presentationml/2006/main" xmlns:r="http://schemas.openxmlformats.org/officeDocument/2006/relationships">
   <p:cSld>
     <p:bg>
@@ -6937,492 +8791,6 @@
                 </a:solidFill>
               </a:rPr>
               <a:t>Connecting report export pipeline with standard GIS format specifications.</a:t>
-            </a:r>
-          </a:p>
-        </p:txBody>
-      </p:sp>
-    </p:spTree>
-  </p:cSld>
-  <p:clrMapOvr>
-    <a:masterClrMapping/>
-  </p:clrMapOvr>
-</p:sld>
-</file>
-
-<file path=ppt/slides/slide2.xml><?xml version="1.0" encoding="utf-8"?>
-<p:sld xmlns:a="http://schemas.openxmlformats.org/drawingml/2006/main" xmlns:p="http://schemas.openxmlformats.org/presentationml/2006/main" xmlns:r="http://schemas.openxmlformats.org/officeDocument/2006/relationships">
-  <p:cSld>
-    <p:bg>
-      <p:bgPr>
-        <a:solidFill>
-          <a:srgbClr val="0B1120"/>
-        </a:solidFill>
-        <a:effectLst/>
-      </p:bgPr>
-    </p:bg>
-    <p:spTree>
-      <p:nvGrpSpPr>
-        <p:cNvPr id="1" name=""/>
-        <p:cNvGrpSpPr/>
-        <p:nvPr/>
-      </p:nvGrpSpPr>
-      <p:grpSpPr/>
-      <p:sp>
-        <p:nvSpPr>
-          <p:cNvPr id="2" name="TextBox 1"/>
-          <p:cNvSpPr txBox="1"/>
-          <p:nvPr/>
-        </p:nvSpPr>
-        <p:spPr>
-          <a:xfrm>
-            <a:off x="731520" y="365760"/>
-            <a:ext cx="10728655" cy="274320"/>
-          </a:xfrm>
-          <a:prstGeom prst="rect">
-            <a:avLst/>
-          </a:prstGeom>
-          <a:noFill/>
-        </p:spPr>
-        <p:txBody>
-          <a:bodyPr wrap="square">
-            <a:spAutoFit/>
-          </a:bodyPr>
-          <a:lstStyle/>
-          <a:p>
-            <a:pPr>
-              <a:defRPr sz="1000" b="1">
-                <a:solidFill>
-                  <a:srgbClr val="00D2FF"/>
-                </a:solidFill>
-                <a:latin typeface="Helvetica"/>
-              </a:defRPr>
-            </a:pPr>
-            <a:r>
-              <a:t>SIH 2026 PS 26227 | GEOSPATIAL INTELLIGENCE PLATFORM</a:t>
-            </a:r>
-          </a:p>
-        </p:txBody>
-      </p:sp>
-      <p:sp>
-        <p:nvSpPr>
-          <p:cNvPr id="3" name="TextBox 2"/>
-          <p:cNvSpPr txBox="1"/>
-          <p:nvPr/>
-        </p:nvSpPr>
-        <p:spPr>
-          <a:xfrm>
-            <a:off x="731520" y="594360"/>
-            <a:ext cx="10728655" cy="548640"/>
-          </a:xfrm>
-          <a:prstGeom prst="rect">
-            <a:avLst/>
-          </a:prstGeom>
-          <a:noFill/>
-        </p:spPr>
-        <p:txBody>
-          <a:bodyPr wrap="square">
-            <a:spAutoFit/>
-          </a:bodyPr>
-          <a:lstStyle/>
-          <a:p>
-            <a:pPr>
-              <a:defRPr sz="2200" b="1">
-                <a:solidFill>
-                  <a:srgbClr val="FFFFFF"/>
-                </a:solidFill>
-                <a:latin typeface="Helvetica"/>
-              </a:defRPr>
-            </a:pPr>
-            <a:r>
-              <a:t>Why Existing Satellite Workflows Break in Operations</a:t>
-            </a:r>
-          </a:p>
-        </p:txBody>
-      </p:sp>
-      <p:sp>
-        <p:nvSpPr>
-          <p:cNvPr id="4" name="Rounded Rectangle 3"/>
-          <p:cNvSpPr/>
-          <p:nvPr/>
-        </p:nvSpPr>
-        <p:spPr>
-          <a:xfrm>
-            <a:off x="731520" y="1371600"/>
-            <a:ext cx="5212080" cy="2286000"/>
-          </a:xfrm>
-          <a:prstGeom prst="roundRect">
-            <a:avLst/>
-          </a:prstGeom>
-          <a:solidFill>
-            <a:srgbClr val="0F172A"/>
-          </a:solidFill>
-          <a:ln w="19050">
-            <a:solidFill>
-              <a:srgbClr val="FF3B30"/>
-            </a:solidFill>
-          </a:ln>
-        </p:spPr>
-        <p:style>
-          <a:lnRef idx="1">
-            <a:schemeClr val="accent1"/>
-          </a:lnRef>
-          <a:fillRef idx="3">
-            <a:schemeClr val="accent1"/>
-          </a:fillRef>
-          <a:effectRef idx="2">
-            <a:schemeClr val="accent1"/>
-          </a:effectRef>
-          <a:fontRef idx="minor">
-            <a:schemeClr val="lt1"/>
-          </a:fontRef>
-        </p:style>
-        <p:txBody>
-          <a:bodyPr rtlCol="0" anchor="ctr"/>
-          <a:lstStyle/>
-          <a:p>
-            <a:pPr algn="ctr"/>
-          </a:p>
-        </p:txBody>
-      </p:sp>
-      <p:sp>
-        <p:nvSpPr>
-          <p:cNvPr id="5" name="TextBox 4"/>
-          <p:cNvSpPr txBox="1"/>
-          <p:nvPr/>
-        </p:nvSpPr>
-        <p:spPr>
-          <a:xfrm>
-            <a:off x="914400" y="1554480"/>
-            <a:ext cx="4846320" cy="1920240"/>
-          </a:xfrm>
-          <a:prstGeom prst="rect">
-            <a:avLst/>
-          </a:prstGeom>
-          <a:noFill/>
-        </p:spPr>
-        <p:txBody>
-          <a:bodyPr wrap="square">
-            <a:spAutoFit/>
-          </a:bodyPr>
-          <a:lstStyle/>
-          <a:p>
-            <a:pPr>
-              <a:defRPr sz="1300" b="1">
-                <a:solidFill>
-                  <a:srgbClr val="FF3B30"/>
-                </a:solidFill>
-              </a:defRPr>
-            </a:pPr>
-            <a:r>
-              <a:t>1. METADATA SEARCH GAP</a:t>
-            </a:r>
-          </a:p>
-          <a:p>
-            <a:pPr>
-              <a:defRPr sz="1100">
-                <a:solidFill>
-                  <a:srgbClr val="FFFFFF"/>
-                </a:solidFill>
-              </a:defRPr>
-            </a:pPr>
-            <a:r>
-              <a:t>Can answer: 'Show region X in 2024'</a:t>
-            </a:r>
-            <a:br/>
-            <a:r>
-              <a:t>Cannot answer: 'Show industrial expansion near river banks'</a:t>
-            </a:r>
-            <a:br/>
-            <a:r>
-              <a:t>Result: Hours spent manually sifting irrelevant scenes.</a:t>
-            </a:r>
-          </a:p>
-        </p:txBody>
-      </p:sp>
-      <p:sp>
-        <p:nvSpPr>
-          <p:cNvPr id="6" name="Rounded Rectangle 5"/>
-          <p:cNvSpPr/>
-          <p:nvPr/>
-        </p:nvSpPr>
-        <p:spPr>
-          <a:xfrm>
-            <a:off x="6172200" y="1371600"/>
-            <a:ext cx="5212080" cy="2286000"/>
-          </a:xfrm>
-          <a:prstGeom prst="roundRect">
-            <a:avLst/>
-          </a:prstGeom>
-          <a:solidFill>
-            <a:srgbClr val="0F172A"/>
-          </a:solidFill>
-          <a:ln w="19050">
-            <a:solidFill>
-              <a:srgbClr val="FF3B30"/>
-            </a:solidFill>
-          </a:ln>
-        </p:spPr>
-        <p:style>
-          <a:lnRef idx="1">
-            <a:schemeClr val="accent1"/>
-          </a:lnRef>
-          <a:fillRef idx="3">
-            <a:schemeClr val="accent1"/>
-          </a:fillRef>
-          <a:effectRef idx="2">
-            <a:schemeClr val="accent1"/>
-          </a:effectRef>
-          <a:fontRef idx="minor">
-            <a:schemeClr val="lt1"/>
-          </a:fontRef>
-        </p:style>
-        <p:txBody>
-          <a:bodyPr rtlCol="0" anchor="ctr"/>
-          <a:lstStyle/>
-          <a:p>
-            <a:pPr algn="ctr"/>
-          </a:p>
-        </p:txBody>
-      </p:sp>
-      <p:sp>
-        <p:nvSpPr>
-          <p:cNvPr id="7" name="TextBox 6"/>
-          <p:cNvSpPr txBox="1"/>
-          <p:nvPr/>
-        </p:nvSpPr>
-        <p:spPr>
-          <a:xfrm>
-            <a:off x="6355080" y="1554480"/>
-            <a:ext cx="4846320" cy="1920240"/>
-          </a:xfrm>
-          <a:prstGeom prst="rect">
-            <a:avLst/>
-          </a:prstGeom>
-          <a:noFill/>
-        </p:spPr>
-        <p:txBody>
-          <a:bodyPr wrap="square">
-            <a:spAutoFit/>
-          </a:bodyPr>
-          <a:lstStyle/>
-          <a:p>
-            <a:pPr>
-              <a:defRPr sz="1300" b="1">
-                <a:solidFill>
-                  <a:srgbClr val="FF3B30"/>
-                </a:solidFill>
-              </a:defRPr>
-            </a:pPr>
-            <a:r>
-              <a:t>2. NAIVE DIFFERENCE NOISE</a:t>
-            </a:r>
-          </a:p>
-          <a:p>
-            <a:pPr>
-              <a:defRPr sz="1100">
-                <a:solidFill>
-                  <a:srgbClr val="FFFFFF"/>
-                </a:solidFill>
-              </a:defRPr>
-            </a:pPr>
-            <a:r>
-              <a:t>Simple pairwise subtraction flags crop growth, cloud shadows, and seasonal phenology as major structural changes.</a:t>
-            </a:r>
-            <a:br/>
-            <a:r>
-              <a:t>Result: 70%+ analyst time wasted on false alarms.</a:t>
-            </a:r>
-          </a:p>
-        </p:txBody>
-      </p:sp>
-      <p:sp>
-        <p:nvSpPr>
-          <p:cNvPr id="8" name="Rounded Rectangle 7"/>
-          <p:cNvSpPr/>
-          <p:nvPr/>
-        </p:nvSpPr>
-        <p:spPr>
-          <a:xfrm>
-            <a:off x="731520" y="3840480"/>
-            <a:ext cx="5212080" cy="2286000"/>
-          </a:xfrm>
-          <a:prstGeom prst="roundRect">
-            <a:avLst/>
-          </a:prstGeom>
-          <a:solidFill>
-            <a:srgbClr val="0F172A"/>
-          </a:solidFill>
-          <a:ln w="19050">
-            <a:solidFill>
-              <a:srgbClr val="FF3B30"/>
-            </a:solidFill>
-          </a:ln>
-        </p:spPr>
-        <p:style>
-          <a:lnRef idx="1">
-            <a:schemeClr val="accent1"/>
-          </a:lnRef>
-          <a:fillRef idx="3">
-            <a:schemeClr val="accent1"/>
-          </a:fillRef>
-          <a:effectRef idx="2">
-            <a:schemeClr val="accent1"/>
-          </a:effectRef>
-          <a:fontRef idx="minor">
-            <a:schemeClr val="lt1"/>
-          </a:fontRef>
-        </p:style>
-        <p:txBody>
-          <a:bodyPr rtlCol="0" anchor="ctr"/>
-          <a:lstStyle/>
-          <a:p>
-            <a:pPr algn="ctr"/>
-          </a:p>
-        </p:txBody>
-      </p:sp>
-      <p:sp>
-        <p:nvSpPr>
-          <p:cNvPr id="9" name="TextBox 8"/>
-          <p:cNvSpPr txBox="1"/>
-          <p:nvPr/>
-        </p:nvSpPr>
-        <p:spPr>
-          <a:xfrm>
-            <a:off x="914400" y="4023360"/>
-            <a:ext cx="4846320" cy="1920240"/>
-          </a:xfrm>
-          <a:prstGeom prst="rect">
-            <a:avLst/>
-          </a:prstGeom>
-          <a:noFill/>
-        </p:spPr>
-        <p:txBody>
-          <a:bodyPr wrap="square">
-            <a:spAutoFit/>
-          </a:bodyPr>
-          <a:lstStyle/>
-          <a:p>
-            <a:pPr>
-              <a:defRPr sz="1300" b="1">
-                <a:solidFill>
-                  <a:srgbClr val="FF3B30"/>
-                </a:solidFill>
-              </a:defRPr>
-            </a:pPr>
-            <a:r>
-              <a:t>3. MANUAL TEMPORAL ANALYSIS</a:t>
-            </a:r>
-          </a:p>
-          <a:p>
-            <a:pPr>
-              <a:defRPr sz="1100">
-                <a:solidFill>
-                  <a:srgbClr val="FFFFFF"/>
-                </a:solidFill>
-              </a:defRPr>
-            </a:pPr>
-            <a:r>
-              <a:t>Comparing multi-year image stacks requires manually overlaying layers across dozens of acquisition dates.</a:t>
-            </a:r>
-            <a:br/>
-            <a:r>
-              <a:t>Result: Critical change onset dates missed.</a:t>
-            </a:r>
-          </a:p>
-        </p:txBody>
-      </p:sp>
-      <p:sp>
-        <p:nvSpPr>
-          <p:cNvPr id="10" name="Rounded Rectangle 9"/>
-          <p:cNvSpPr/>
-          <p:nvPr/>
-        </p:nvSpPr>
-        <p:spPr>
-          <a:xfrm>
-            <a:off x="6172200" y="3840480"/>
-            <a:ext cx="5212080" cy="2286000"/>
-          </a:xfrm>
-          <a:prstGeom prst="roundRect">
-            <a:avLst/>
-          </a:prstGeom>
-          <a:solidFill>
-            <a:srgbClr val="0F172A"/>
-          </a:solidFill>
-          <a:ln w="19050">
-            <a:solidFill>
-              <a:srgbClr val="FF3B30"/>
-            </a:solidFill>
-          </a:ln>
-        </p:spPr>
-        <p:style>
-          <a:lnRef idx="1">
-            <a:schemeClr val="accent1"/>
-          </a:lnRef>
-          <a:fillRef idx="3">
-            <a:schemeClr val="accent1"/>
-          </a:fillRef>
-          <a:effectRef idx="2">
-            <a:schemeClr val="accent1"/>
-          </a:effectRef>
-          <a:fontRef idx="minor">
-            <a:schemeClr val="lt1"/>
-          </a:fontRef>
-        </p:style>
-        <p:txBody>
-          <a:bodyPr rtlCol="0" anchor="ctr"/>
-          <a:lstStyle/>
-          <a:p>
-            <a:pPr algn="ctr"/>
-          </a:p>
-        </p:txBody>
-      </p:sp>
-      <p:sp>
-        <p:nvSpPr>
-          <p:cNvPr id="11" name="TextBox 10"/>
-          <p:cNvSpPr txBox="1"/>
-          <p:nvPr/>
-        </p:nvSpPr>
-        <p:spPr>
-          <a:xfrm>
-            <a:off x="6355080" y="4023360"/>
-            <a:ext cx="4846320" cy="1920240"/>
-          </a:xfrm>
-          <a:prstGeom prst="rect">
-            <a:avLst/>
-          </a:prstGeom>
-          <a:noFill/>
-        </p:spPr>
-        <p:txBody>
-          <a:bodyPr wrap="square">
-            <a:spAutoFit/>
-          </a:bodyPr>
-          <a:lstStyle/>
-          <a:p>
-            <a:pPr>
-              <a:defRPr sz="1300" b="1">
-                <a:solidFill>
-                  <a:srgbClr val="FF3B30"/>
-                </a:solidFill>
-              </a:defRPr>
-            </a:pPr>
-            <a:r>
-              <a:t>4. LACK OF PROVENANCE &amp; TRUST</a:t>
-            </a:r>
-          </a:p>
-          <a:p>
-            <a:pPr>
-              <a:defRPr sz="1100">
-                <a:solidFill>
-                  <a:srgbClr val="FFFFFF"/>
-                </a:solidFill>
-              </a:defRPr>
-            </a:pPr>
-            <a:r>
-              <a:t>Standalone deep learning models output raw bounding boxes without processing logs, metadata, or confidence scores.</a:t>
-            </a:r>
-            <a:br/>
-            <a:r>
-              <a:t>Result: Unverifiable intelligence.</a:t>
             </a:r>
           </a:p>
         </p:txBody>

</xml_diff>